<commit_message>
Update report title slide with system diagram
</commit_message>
<xml_diff>
--- a/reports/MDLA7_System_Report.pptx
+++ b/reports/MDLA7_System_Report.pptx
@@ -3227,27 +3227,28 @@
         </p:nvSpPr>
         <p:spPr>
           <a:xfrm>
-            <a:off x="685800" y="566928"/>
-            <a:ext cx="8686800" cy="731520"/>
-          </a:xfrm>
-          <a:prstGeom prst="rect">
-            <a:avLst/>
-          </a:prstGeom>
-          <a:noFill/>
-        </p:spPr>
-        <p:txBody>
-          <a:bodyPr wrap="square" lIns="36576" rIns="36576" tIns="18288" bIns="18288">
-            <a:spAutoFit/>
-          </a:bodyPr>
-          <a:lstStyle/>
-          <a:p>
-            <a:r>
-              <a:rPr sz="3100" b="1">
+            <a:off x="457200" y="228600"/>
+            <a:ext cx="6675120" cy="347472"/>
+          </a:xfrm>
+          <a:prstGeom prst="rect">
+            <a:avLst/>
+          </a:prstGeom>
+          <a:noFill/>
+        </p:spPr>
+        <p:txBody>
+          <a:bodyPr wrap="square" lIns="36576" rIns="36576" tIns="18288" bIns="18288">
+            <a:spAutoFit/>
+          </a:bodyPr>
+          <a:lstStyle/>
+          <a:p>
+            <a:pPr algn="l"/>
+            <a:r>
+              <a:rPr sz="2400" b="1">
                 <a:solidFill>
                   <a:srgbClr val="183458"/>
                 </a:solidFill>
               </a:rPr>
-              <a:t>MDLA7 SystemC Model and Performance Optimization</a:t>
+              <a:t>MDLA7 System Block Diagram</a:t>
             </a:r>
           </a:p>
         </p:txBody>
@@ -3260,27 +3261,28 @@
         </p:nvSpPr>
         <p:spPr>
           <a:xfrm>
-            <a:off x="713232" y="1325880"/>
-            <a:ext cx="7498079" cy="411480"/>
-          </a:xfrm>
-          <a:prstGeom prst="rect">
-            <a:avLst/>
-          </a:prstGeom>
-          <a:noFill/>
-        </p:spPr>
-        <p:txBody>
-          <a:bodyPr wrap="square" lIns="36576" rIns="36576" tIns="18288" bIns="18288">
-            <a:spAutoFit/>
-          </a:bodyPr>
-          <a:lstStyle/>
-          <a:p>
-            <a:r>
-              <a:rPr sz="1600" b="0">
+            <a:off x="475488" y="621792"/>
+            <a:ext cx="6217920" cy="219456"/>
+          </a:xfrm>
+          <a:prstGeom prst="rect">
+            <a:avLst/>
+          </a:prstGeom>
+          <a:noFill/>
+        </p:spPr>
+        <p:txBody>
+          <a:bodyPr wrap="square" lIns="36576" rIns="36576" tIns="18288" bIns="18288">
+            <a:spAutoFit/>
+          </a:bodyPr>
+          <a:lstStyle/>
+          <a:p>
+            <a:pPr algn="l"/>
+            <a:r>
+              <a:rPr sz="1000" b="0">
                 <a:solidFill>
                   <a:srgbClr val="5E6875"/>
                 </a:solidFill>
               </a:rPr>
-              <a:t>Architecture, module throughput, tuning history, regression status, and synthesis gaps</a:t>
+              <a:t>Based on spec/mdla7.drawio; updated to current MDLA7 SystemC model</a:t>
             </a:r>
           </a:p>
         </p:txBody>
@@ -3293,17 +3295,19 @@
         </p:nvSpPr>
         <p:spPr>
           <a:xfrm>
-            <a:off x="822960" y="2834640"/>
-            <a:ext cx="1143000" cy="731520"/>
+            <a:off x="7406640" y="228600"/>
+            <a:ext cx="4251960" cy="960120"/>
           </a:xfrm>
           <a:prstGeom prst="roundRect">
             <a:avLst/>
           </a:prstGeom>
           <a:solidFill>
-            <a:srgbClr val="183458"/>
+            <a:srgbClr val="F5F7FA"/>
           </a:solidFill>
           <a:ln>
-            <a:noFill/>
+            <a:solidFill>
+              <a:srgbClr val="00897B"/>
+            </a:solidFill>
           </a:ln>
         </p:spPr>
         <p:style>
@@ -3321,7 +3325,7 @@
           </a:fontRef>
         </p:style>
         <p:txBody>
-          <a:bodyPr rtlCol="0" anchor="ctr" lIns="36576" rIns="36576" tIns="18288" bIns="18288"/>
+          <a:bodyPr rtlCol="0" anchor="ctr"/>
           <a:lstStyle/>
           <a:p>
             <a:pPr algn="ctr"/>
@@ -3336,52 +3340,89 @@
         </p:nvSpPr>
         <p:spPr>
           <a:xfrm>
-            <a:off x="877824" y="2990088"/>
-            <a:ext cx="1033271" cy="347472"/>
-          </a:xfrm>
-          <a:prstGeom prst="rect">
-            <a:avLst/>
-          </a:prstGeom>
-          <a:noFill/>
-        </p:spPr>
-        <p:txBody>
-          <a:bodyPr wrap="square" lIns="36576" rIns="36576" tIns="18288" bIns="18288">
-            <a:spAutoFit/>
-          </a:bodyPr>
-          <a:lstStyle/>
-          <a:p>
-            <a:pPr algn="ctr"/>
-            <a:r>
-              <a:rPr sz="1300" b="1">
-                <a:solidFill>
-                  <a:srgbClr val="FFFFFF"/>
-                </a:solidFill>
-              </a:rPr>
-              <a:t>RISC-V
-Host</a:t>
-            </a:r>
-          </a:p>
-        </p:txBody>
-      </p:sp>
-      <p:sp>
-        <p:nvSpPr>
-          <p:cNvPr id="6" name="Rounded Rectangle 5"/>
+            <a:off x="7498079" y="338328"/>
+            <a:ext cx="4069080" cy="228600"/>
+          </a:xfrm>
+          <a:prstGeom prst="rect">
+            <a:avLst/>
+          </a:prstGeom>
+          <a:noFill/>
+        </p:spPr>
+        <p:txBody>
+          <a:bodyPr wrap="square" lIns="36576" rIns="36576" tIns="18288" bIns="18288">
+            <a:spAutoFit/>
+          </a:bodyPr>
+          <a:lstStyle/>
+          <a:p>
+            <a:pPr algn="ctr"/>
+            <a:r>
+              <a:rPr sz="1200" b="1">
+                <a:solidFill>
+                  <a:srgbClr val="00897B"/>
+                </a:solidFill>
+              </a:rPr>
+              <a:t>System Parameters</a:t>
+            </a:r>
+          </a:p>
+        </p:txBody>
+      </p:sp>
+      <p:sp>
+        <p:nvSpPr>
+          <p:cNvPr id="6" name="TextBox 5"/>
+          <p:cNvSpPr txBox="1"/>
+          <p:nvPr/>
+        </p:nvSpPr>
+        <p:spPr>
+          <a:xfrm>
+            <a:off x="7516367" y="630936"/>
+            <a:ext cx="4032504" cy="484632"/>
+          </a:xfrm>
+          <a:prstGeom prst="rect">
+            <a:avLst/>
+          </a:prstGeom>
+          <a:noFill/>
+        </p:spPr>
+        <p:txBody>
+          <a:bodyPr wrap="square" lIns="36576" rIns="36576" tIns="18288" bIns="18288">
+            <a:spAutoFit/>
+          </a:bodyPr>
+          <a:lstStyle/>
+          <a:p>
+            <a:pPr algn="ctr"/>
+            <a:r>
+              <a:rPr sz="880" b="0">
+                <a:solidFill>
+                  <a:srgbClr val="191C21"/>
+                </a:solidFill>
+              </a:rPr>
+              <a:t>1.9 GHz core | 62.3 TOPS INT8x8 baseline
+3 MB L1Mesh SRAM | LPDDR5X-10667, dual x32
+64B descriptors via DRAM ring + MMIO doorbell</a:t>
+            </a:r>
+          </a:p>
+        </p:txBody>
+      </p:sp>
+      <p:sp>
+        <p:nvSpPr>
+          <p:cNvPr id="7" name="Rounded Rectangle 6"/>
           <p:cNvSpPr/>
           <p:nvPr/>
         </p:nvSpPr>
         <p:spPr>
           <a:xfrm>
-            <a:off x="2286000" y="2834640"/>
-            <a:ext cx="1143000" cy="731520"/>
+            <a:off x="502920" y="1417320"/>
+            <a:ext cx="1143000" cy="594360"/>
           </a:xfrm>
           <a:prstGeom prst="roundRect">
             <a:avLst/>
           </a:prstGeom>
           <a:solidFill>
-            <a:srgbClr val="00897B"/>
+            <a:srgbClr val="E08430"/>
           </a:solidFill>
           <a:ln>
-            <a:noFill/>
+            <a:solidFill>
+              <a:srgbClr val="E08430"/>
+            </a:solidFill>
           </a:ln>
         </p:spPr>
         <p:style>
@@ -3399,67 +3440,103 @@
           </a:fontRef>
         </p:style>
         <p:txBody>
-          <a:bodyPr rtlCol="0" anchor="ctr" lIns="36576" rIns="36576" tIns="18288" bIns="18288"/>
-          <a:lstStyle/>
-          <a:p>
-            <a:pPr algn="ctr"/>
-          </a:p>
-        </p:txBody>
-      </p:sp>
-      <p:sp>
-        <p:nvSpPr>
-          <p:cNvPr id="7" name="TextBox 6"/>
-          <p:cNvSpPr txBox="1"/>
-          <p:nvPr/>
-        </p:nvSpPr>
-        <p:spPr>
-          <a:xfrm>
-            <a:off x="2340864" y="2990088"/>
-            <a:ext cx="1033271" cy="347472"/>
-          </a:xfrm>
-          <a:prstGeom prst="rect">
-            <a:avLst/>
-          </a:prstGeom>
-          <a:noFill/>
-        </p:spPr>
-        <p:txBody>
-          <a:bodyPr wrap="square" lIns="36576" rIns="36576" tIns="18288" bIns="18288">
-            <a:spAutoFit/>
-          </a:bodyPr>
-          <a:lstStyle/>
-          <a:p>
-            <a:pPr algn="ctr"/>
-            <a:r>
-              <a:rPr sz="1300" b="1">
+          <a:bodyPr rtlCol="0" anchor="ctr"/>
+          <a:lstStyle/>
+          <a:p>
+            <a:pPr algn="ctr"/>
+          </a:p>
+        </p:txBody>
+      </p:sp>
+      <p:sp>
+        <p:nvSpPr>
+          <p:cNvPr id="8" name="TextBox 7"/>
+          <p:cNvSpPr txBox="1"/>
+          <p:nvPr/>
+        </p:nvSpPr>
+        <p:spPr>
+          <a:xfrm>
+            <a:off x="576072" y="1527048"/>
+            <a:ext cx="996696" cy="228600"/>
+          </a:xfrm>
+          <a:prstGeom prst="rect">
+            <a:avLst/>
+          </a:prstGeom>
+          <a:noFill/>
+        </p:spPr>
+        <p:txBody>
+          <a:bodyPr wrap="square" lIns="36576" rIns="36576" tIns="18288" bIns="18288">
+            <a:spAutoFit/>
+          </a:bodyPr>
+          <a:lstStyle/>
+          <a:p>
+            <a:pPr algn="ctr"/>
+            <a:r>
+              <a:rPr sz="1200" b="1">
                 <a:solidFill>
                   <a:srgbClr val="FFFFFF"/>
                 </a:solidFill>
               </a:rPr>
-              <a:t>Cmd
-Engine</a:t>
-            </a:r>
-          </a:p>
-        </p:txBody>
-      </p:sp>
-      <p:sp>
-        <p:nvSpPr>
-          <p:cNvPr id="8" name="Rounded Rectangle 7"/>
+              <a:t>Host</a:t>
+            </a:r>
+          </a:p>
+        </p:txBody>
+      </p:sp>
+      <p:sp>
+        <p:nvSpPr>
+          <p:cNvPr id="9" name="TextBox 8"/>
+          <p:cNvSpPr txBox="1"/>
+          <p:nvPr/>
+        </p:nvSpPr>
+        <p:spPr>
+          <a:xfrm>
+            <a:off x="612648" y="1810512"/>
+            <a:ext cx="923544" cy="137160"/>
+          </a:xfrm>
+          <a:prstGeom prst="rect">
+            <a:avLst/>
+          </a:prstGeom>
+          <a:noFill/>
+        </p:spPr>
+        <p:txBody>
+          <a:bodyPr wrap="square" lIns="36576" rIns="36576" tIns="18288" bIns="18288">
+            <a:spAutoFit/>
+          </a:bodyPr>
+          <a:lstStyle/>
+          <a:p>
+            <a:pPr algn="ctr"/>
+            <a:r>
+              <a:rPr sz="850" b="0">
+                <a:solidFill>
+                  <a:srgbClr val="FFFFFF"/>
+                </a:solidFill>
+              </a:rPr>
+              <a:t>RISC-V
+MMIO doorbell</a:t>
+            </a:r>
+          </a:p>
+        </p:txBody>
+      </p:sp>
+      <p:sp>
+        <p:nvSpPr>
+          <p:cNvPr id="10" name="Rounded Rectangle 9"/>
           <p:cNvSpPr/>
           <p:nvPr/>
         </p:nvSpPr>
         <p:spPr>
           <a:xfrm>
-            <a:off x="3749039" y="2834640"/>
-            <a:ext cx="1143000" cy="731520"/>
+            <a:off x="1965960" y="1417320"/>
+            <a:ext cx="9235440" cy="594360"/>
           </a:xfrm>
           <a:prstGeom prst="roundRect">
             <a:avLst/>
           </a:prstGeom>
           <a:solidFill>
-            <a:srgbClr val="398E5A"/>
+            <a:srgbClr val="183458"/>
           </a:solidFill>
           <a:ln>
-            <a:noFill/>
+            <a:solidFill>
+              <a:srgbClr val="183458"/>
+            </a:solidFill>
           </a:ln>
         </p:spPr>
         <p:style>
@@ -3477,67 +3554,172 @@
           </a:fontRef>
         </p:style>
         <p:txBody>
-          <a:bodyPr rtlCol="0" anchor="ctr" lIns="36576" rIns="36576" tIns="18288" bIns="18288"/>
-          <a:lstStyle/>
-          <a:p>
-            <a:pPr algn="ctr"/>
-          </a:p>
-        </p:txBody>
-      </p:sp>
-      <p:sp>
-        <p:nvSpPr>
-          <p:cNvPr id="9" name="TextBox 8"/>
-          <p:cNvSpPr txBox="1"/>
-          <p:nvPr/>
-        </p:nvSpPr>
-        <p:spPr>
-          <a:xfrm>
-            <a:off x="3803903" y="2990088"/>
-            <a:ext cx="1033271" cy="347472"/>
-          </a:xfrm>
-          <a:prstGeom prst="rect">
-            <a:avLst/>
-          </a:prstGeom>
-          <a:noFill/>
-        </p:spPr>
-        <p:txBody>
-          <a:bodyPr wrap="square" lIns="36576" rIns="36576" tIns="18288" bIns="18288">
-            <a:spAutoFit/>
-          </a:bodyPr>
-          <a:lstStyle/>
-          <a:p>
-            <a:pPr algn="ctr"/>
-            <a:r>
-              <a:rPr sz="1300" b="1">
+          <a:bodyPr rtlCol="0" anchor="ctr"/>
+          <a:lstStyle/>
+          <a:p>
+            <a:pPr algn="ctr"/>
+          </a:p>
+        </p:txBody>
+      </p:sp>
+      <p:sp>
+        <p:nvSpPr>
+          <p:cNvPr id="11" name="TextBox 10"/>
+          <p:cNvSpPr txBox="1"/>
+          <p:nvPr/>
+        </p:nvSpPr>
+        <p:spPr>
+          <a:xfrm>
+            <a:off x="2039112" y="1527048"/>
+            <a:ext cx="9089136" cy="228600"/>
+          </a:xfrm>
+          <a:prstGeom prst="rect">
+            <a:avLst/>
+          </a:prstGeom>
+          <a:noFill/>
+        </p:spPr>
+        <p:txBody>
+          <a:bodyPr wrap="square" lIns="36576" rIns="36576" tIns="18288" bIns="18288">
+            <a:spAutoFit/>
+          </a:bodyPr>
+          <a:lstStyle/>
+          <a:p>
+            <a:pPr algn="ctr"/>
+            <a:r>
+              <a:rPr sz="1200" b="1">
                 <a:solidFill>
                   <a:srgbClr val="FFFFFF"/>
                 </a:solidFill>
               </a:rPr>
-              <a:t>L1Mesh
-3 MB</a:t>
-            </a:r>
-          </a:p>
-        </p:txBody>
-      </p:sp>
-      <p:sp>
-        <p:nvSpPr>
-          <p:cNvPr id="10" name="Rounded Rectangle 9"/>
+              <a:t>Command Engine</a:t>
+            </a:r>
+          </a:p>
+        </p:txBody>
+      </p:sp>
+      <p:sp>
+        <p:nvSpPr>
+          <p:cNvPr id="12" name="TextBox 11"/>
+          <p:cNvSpPr txBox="1"/>
+          <p:nvPr/>
+        </p:nvSpPr>
+        <p:spPr>
+          <a:xfrm>
+            <a:off x="2075688" y="1810512"/>
+            <a:ext cx="9015984" cy="137160"/>
+          </a:xfrm>
+          <a:prstGeom prst="rect">
+            <a:avLst/>
+          </a:prstGeom>
+          <a:noFill/>
+        </p:spPr>
+        <p:txBody>
+          <a:bodyPr wrap="square" lIns="36576" rIns="36576" tIns="18288" bIns="18288">
+            <a:spAutoFit/>
+          </a:bodyPr>
+          <a:lstStyle/>
+          <a:p>
+            <a:pPr algn="ctr"/>
+            <a:r>
+              <a:rPr sz="850" b="0">
+                <a:solidFill>
+                  <a:srgbClr val="FFFFFF"/>
+                </a:solidFill>
+              </a:rPr>
+              <a:t>Descriptor decode + dependency tracker + per-engine config dispatch</a:t>
+            </a:r>
+          </a:p>
+        </p:txBody>
+      </p:sp>
+      <p:cxnSp>
+        <p:nvCxnSpPr>
+          <p:cNvPr id="13" name="Connector 12"/>
+          <p:cNvCxnSpPr/>
+          <p:nvPr/>
+        </p:nvCxnSpPr>
+        <p:spPr>
+          <a:xfrm>
+            <a:off x="1645920" y="1719072"/>
+            <a:ext cx="320040" cy="0"/>
+          </a:xfrm>
+          <a:prstGeom prst="line">
+            <a:avLst/>
+          </a:prstGeom>
+          <a:ln w="19050">
+            <a:solidFill>
+              <a:srgbClr val="5E6875"/>
+            </a:solidFill>
+            <a:prstDash val="dash"/>
+          </a:ln>
+        </p:spPr>
+        <p:style>
+          <a:lnRef idx="2">
+            <a:schemeClr val="accent1"/>
+          </a:lnRef>
+          <a:fillRef idx="0">
+            <a:schemeClr val="accent1"/>
+          </a:fillRef>
+          <a:effectRef idx="1">
+            <a:schemeClr val="accent1"/>
+          </a:effectRef>
+          <a:fontRef idx="minor">
+            <a:schemeClr val="tx1"/>
+          </a:fontRef>
+        </p:style>
+      </p:cxnSp>
+      <p:sp>
+        <p:nvSpPr>
+          <p:cNvPr id="14" name="TextBox 13"/>
+          <p:cNvSpPr txBox="1"/>
+          <p:nvPr/>
+        </p:nvSpPr>
+        <p:spPr>
+          <a:xfrm>
+            <a:off x="1627632" y="1444752"/>
+            <a:ext cx="320040" cy="182880"/>
+          </a:xfrm>
+          <a:prstGeom prst="rect">
+            <a:avLst/>
+          </a:prstGeom>
+          <a:noFill/>
+        </p:spPr>
+        <p:txBody>
+          <a:bodyPr wrap="square" lIns="36576" rIns="36576" tIns="18288" bIns="18288">
+            <a:spAutoFit/>
+          </a:bodyPr>
+          <a:lstStyle/>
+          <a:p>
+            <a:pPr algn="ctr"/>
+            <a:r>
+              <a:rPr sz="750" b="1">
+                <a:solidFill>
+                  <a:srgbClr val="5E6875"/>
+                </a:solidFill>
+              </a:rPr>
+              <a:t>1T</a:t>
+            </a:r>
+          </a:p>
+        </p:txBody>
+      </p:sp>
+      <p:sp>
+        <p:nvSpPr>
+          <p:cNvPr id="15" name="Rounded Rectangle 14"/>
           <p:cNvSpPr/>
           <p:nvPr/>
         </p:nvSpPr>
         <p:spPr>
           <a:xfrm>
-            <a:off x="5394960" y="2834640"/>
-            <a:ext cx="1143000" cy="731520"/>
+            <a:off x="594360" y="2423160"/>
+            <a:ext cx="1645920" cy="1051560"/>
           </a:xfrm>
           <a:prstGeom prst="roundRect">
             <a:avLst/>
           </a:prstGeom>
           <a:solidFill>
-            <a:srgbClr val="E08430"/>
+            <a:srgbClr val="398E5A"/>
           </a:solidFill>
           <a:ln>
-            <a:noFill/>
+            <a:solidFill>
+              <a:srgbClr val="398E5A"/>
+            </a:solidFill>
           </a:ln>
         </p:spPr>
         <p:style>
@@ -3555,67 +3737,104 @@
           </a:fontRef>
         </p:style>
         <p:txBody>
-          <a:bodyPr rtlCol="0" anchor="ctr" lIns="36576" rIns="36576" tIns="18288" bIns="18288"/>
-          <a:lstStyle/>
-          <a:p>
-            <a:pPr algn="ctr"/>
-          </a:p>
-        </p:txBody>
-      </p:sp>
-      <p:sp>
-        <p:nvSpPr>
-          <p:cNvPr id="11" name="TextBox 10"/>
-          <p:cNvSpPr txBox="1"/>
-          <p:nvPr/>
-        </p:nvSpPr>
-        <p:spPr>
-          <a:xfrm>
-            <a:off x="5449824" y="2990088"/>
-            <a:ext cx="1033271" cy="347472"/>
-          </a:xfrm>
-          <a:prstGeom prst="rect">
-            <a:avLst/>
-          </a:prstGeom>
-          <a:noFill/>
-        </p:spPr>
-        <p:txBody>
-          <a:bodyPr wrap="square" lIns="36576" rIns="36576" tIns="18288" bIns="18288">
-            <a:spAutoFit/>
-          </a:bodyPr>
-          <a:lstStyle/>
-          <a:p>
-            <a:pPr algn="ctr"/>
-            <a:r>
-              <a:rPr sz="1300" b="1">
+          <a:bodyPr rtlCol="0" anchor="ctr"/>
+          <a:lstStyle/>
+          <a:p>
+            <a:pPr algn="ctr"/>
+          </a:p>
+        </p:txBody>
+      </p:sp>
+      <p:sp>
+        <p:nvSpPr>
+          <p:cNvPr id="16" name="TextBox 15"/>
+          <p:cNvSpPr txBox="1"/>
+          <p:nvPr/>
+        </p:nvSpPr>
+        <p:spPr>
+          <a:xfrm>
+            <a:off x="667512" y="2532888"/>
+            <a:ext cx="1499616" cy="228600"/>
+          </a:xfrm>
+          <a:prstGeom prst="rect">
+            <a:avLst/>
+          </a:prstGeom>
+          <a:noFill/>
+        </p:spPr>
+        <p:txBody>
+          <a:bodyPr wrap="square" lIns="36576" rIns="36576" tIns="18288" bIns="18288">
+            <a:spAutoFit/>
+          </a:bodyPr>
+          <a:lstStyle/>
+          <a:p>
+            <a:pPr algn="ctr"/>
+            <a:r>
+              <a:rPr sz="1200" b="1">
                 <a:solidFill>
                   <a:srgbClr val="FFFFFF"/>
                 </a:solidFill>
               </a:rPr>
-              <a:t>Compute
-Engines</a:t>
-            </a:r>
-          </a:p>
-        </p:txBody>
-      </p:sp>
-      <p:sp>
-        <p:nvSpPr>
-          <p:cNvPr id="12" name="Rounded Rectangle 11"/>
+              <a:t>CONV Engine</a:t>
+            </a:r>
+          </a:p>
+        </p:txBody>
+      </p:sp>
+      <p:sp>
+        <p:nvSpPr>
+          <p:cNvPr id="17" name="TextBox 16"/>
+          <p:cNvSpPr txBox="1"/>
+          <p:nvPr/>
+        </p:nvSpPr>
+        <p:spPr>
+          <a:xfrm>
+            <a:off x="704088" y="2816352"/>
+            <a:ext cx="1426464" cy="594359"/>
+          </a:xfrm>
+          <a:prstGeom prst="rect">
+            <a:avLst/>
+          </a:prstGeom>
+          <a:noFill/>
+        </p:spPr>
+        <p:txBody>
+          <a:bodyPr wrap="square" lIns="36576" rIns="36576" tIns="18288" bIns="18288">
+            <a:spAutoFit/>
+          </a:bodyPr>
+          <a:lstStyle/>
+          <a:p>
+            <a:pPr algn="ctr"/>
+            <a:r>
+              <a:rPr sz="850" b="0">
+                <a:solidFill>
+                  <a:srgbClr val="FFFFFF"/>
+                </a:solidFill>
+              </a:rPr>
+              <a:t>65,536 base 4x4 cells
+16 clusters, 4 FP
+Bit-decomposable INT+FP</a:t>
+            </a:r>
+          </a:p>
+        </p:txBody>
+      </p:sp>
+      <p:sp>
+        <p:nvSpPr>
+          <p:cNvPr id="18" name="Rounded Rectangle 17"/>
           <p:cNvSpPr/>
           <p:nvPr/>
         </p:nvSpPr>
         <p:spPr>
           <a:xfrm>
-            <a:off x="7223760" y="2834640"/>
-            <a:ext cx="1143000" cy="731520"/>
+            <a:off x="2496312" y="2423160"/>
+            <a:ext cx="1645920" cy="1051560"/>
           </a:xfrm>
           <a:prstGeom prst="roundRect">
             <a:avLst/>
           </a:prstGeom>
           <a:solidFill>
-            <a:srgbClr val="5E6875"/>
+            <a:srgbClr val="00897B"/>
           </a:solidFill>
           <a:ln>
-            <a:noFill/>
+            <a:solidFill>
+              <a:srgbClr val="00897B"/>
+            </a:solidFill>
           </a:ln>
         </p:spPr>
         <p:style>
@@ -3633,293 +3852,2106 @@
           </a:fontRef>
         </p:style>
         <p:txBody>
-          <a:bodyPr rtlCol="0" anchor="ctr" lIns="36576" rIns="36576" tIns="18288" bIns="18288"/>
-          <a:lstStyle/>
-          <a:p>
-            <a:pPr algn="ctr"/>
-          </a:p>
-        </p:txBody>
-      </p:sp>
-      <p:sp>
-        <p:nvSpPr>
-          <p:cNvPr id="13" name="TextBox 12"/>
-          <p:cNvSpPr txBox="1"/>
-          <p:nvPr/>
-        </p:nvSpPr>
-        <p:spPr>
-          <a:xfrm>
-            <a:off x="7278624" y="2990088"/>
-            <a:ext cx="1033271" cy="347472"/>
-          </a:xfrm>
-          <a:prstGeom prst="rect">
-            <a:avLst/>
-          </a:prstGeom>
-          <a:noFill/>
-        </p:spPr>
-        <p:txBody>
-          <a:bodyPr wrap="square" lIns="36576" rIns="36576" tIns="18288" bIns="18288">
-            <a:spAutoFit/>
-          </a:bodyPr>
-          <a:lstStyle/>
-          <a:p>
-            <a:pPr algn="ctr"/>
-            <a:r>
-              <a:rPr sz="1300" b="1">
+          <a:bodyPr rtlCol="0" anchor="ctr"/>
+          <a:lstStyle/>
+          <a:p>
+            <a:pPr algn="ctr"/>
+          </a:p>
+        </p:txBody>
+      </p:sp>
+      <p:sp>
+        <p:nvSpPr>
+          <p:cNvPr id="19" name="TextBox 18"/>
+          <p:cNvSpPr txBox="1"/>
+          <p:nvPr/>
+        </p:nvSpPr>
+        <p:spPr>
+          <a:xfrm>
+            <a:off x="2569464" y="2532888"/>
+            <a:ext cx="1499616" cy="228600"/>
+          </a:xfrm>
+          <a:prstGeom prst="rect">
+            <a:avLst/>
+          </a:prstGeom>
+          <a:noFill/>
+        </p:spPr>
+        <p:txBody>
+          <a:bodyPr wrap="square" lIns="36576" rIns="36576" tIns="18288" bIns="18288">
+            <a:spAutoFit/>
+          </a:bodyPr>
+          <a:lstStyle/>
+          <a:p>
+            <a:pPr algn="ctr"/>
+            <a:r>
+              <a:rPr sz="1200" b="1">
                 <a:solidFill>
                   <a:srgbClr val="FFFFFF"/>
                 </a:solidFill>
               </a:rPr>
-              <a:t>LPDDR5X
-DRAM</a:t>
-            </a:r>
-          </a:p>
-        </p:txBody>
-      </p:sp>
-      <p:sp>
-        <p:nvSpPr>
-          <p:cNvPr id="14" name="TextBox 13"/>
-          <p:cNvSpPr txBox="1"/>
-          <p:nvPr/>
-        </p:nvSpPr>
-        <p:spPr>
-          <a:xfrm>
-            <a:off x="1965960" y="2999232"/>
-            <a:ext cx="411480" cy="274320"/>
-          </a:xfrm>
-          <a:prstGeom prst="rect">
-            <a:avLst/>
-          </a:prstGeom>
-          <a:noFill/>
-        </p:spPr>
-        <p:txBody>
-          <a:bodyPr wrap="square" lIns="36576" rIns="36576" tIns="18288" bIns="18288">
-            <a:spAutoFit/>
-          </a:bodyPr>
-          <a:lstStyle/>
-          <a:p>
-            <a:pPr algn="ctr"/>
-            <a:r>
-              <a:rPr sz="2000" b="1">
+              <a:t>Requant</a:t>
+            </a:r>
+          </a:p>
+        </p:txBody>
+      </p:sp>
+      <p:sp>
+        <p:nvSpPr>
+          <p:cNvPr id="20" name="TextBox 19"/>
+          <p:cNvSpPr txBox="1"/>
+          <p:nvPr/>
+        </p:nvSpPr>
+        <p:spPr>
+          <a:xfrm>
+            <a:off x="2606040" y="2816352"/>
+            <a:ext cx="1426464" cy="594359"/>
+          </a:xfrm>
+          <a:prstGeom prst="rect">
+            <a:avLst/>
+          </a:prstGeom>
+          <a:noFill/>
+        </p:spPr>
+        <p:txBody>
+          <a:bodyPr wrap="square" lIns="36576" rIns="36576" tIns="18288" bIns="18288">
+            <a:spAutoFit/>
+          </a:bodyPr>
+          <a:lstStyle/>
+          <a:p>
+            <a:pPr algn="ctr"/>
+            <a:r>
+              <a:rPr sz="850" b="0">
+                <a:solidFill>
+                  <a:srgbClr val="FFFFFF"/>
+                </a:solidFill>
+              </a:rPr>
+              <a:t>16 per-cluster lanes
+INT32 -&gt; INT8/INT16
+scale + shift + zp</a:t>
+            </a:r>
+          </a:p>
+        </p:txBody>
+      </p:sp>
+      <p:sp>
+        <p:nvSpPr>
+          <p:cNvPr id="21" name="Rounded Rectangle 20"/>
+          <p:cNvSpPr/>
+          <p:nvPr/>
+        </p:nvSpPr>
+        <p:spPr>
+          <a:xfrm>
+            <a:off x="4398264" y="2423160"/>
+            <a:ext cx="1645920" cy="1051560"/>
+          </a:xfrm>
+          <a:prstGeom prst="roundRect">
+            <a:avLst/>
+          </a:prstGeom>
+          <a:solidFill>
+            <a:srgbClr val="7E5792"/>
+          </a:solidFill>
+          <a:ln>
+            <a:solidFill>
+              <a:srgbClr val="7E5792"/>
+            </a:solidFill>
+          </a:ln>
+        </p:spPr>
+        <p:style>
+          <a:lnRef idx="1">
+            <a:schemeClr val="accent1"/>
+          </a:lnRef>
+          <a:fillRef idx="3">
+            <a:schemeClr val="accent1"/>
+          </a:fillRef>
+          <a:effectRef idx="2">
+            <a:schemeClr val="accent1"/>
+          </a:effectRef>
+          <a:fontRef idx="minor">
+            <a:schemeClr val="lt1"/>
+          </a:fontRef>
+        </p:style>
+        <p:txBody>
+          <a:bodyPr rtlCol="0" anchor="ctr"/>
+          <a:lstStyle/>
+          <a:p>
+            <a:pPr algn="ctr"/>
+          </a:p>
+        </p:txBody>
+      </p:sp>
+      <p:sp>
+        <p:nvSpPr>
+          <p:cNvPr id="22" name="TextBox 21"/>
+          <p:cNvSpPr txBox="1"/>
+          <p:nvPr/>
+        </p:nvSpPr>
+        <p:spPr>
+          <a:xfrm>
+            <a:off x="4471416" y="2532888"/>
+            <a:ext cx="1499616" cy="228600"/>
+          </a:xfrm>
+          <a:prstGeom prst="rect">
+            <a:avLst/>
+          </a:prstGeom>
+          <a:noFill/>
+        </p:spPr>
+        <p:txBody>
+          <a:bodyPr wrap="square" lIns="36576" rIns="36576" tIns="18288" bIns="18288">
+            <a:spAutoFit/>
+          </a:bodyPr>
+          <a:lstStyle/>
+          <a:p>
+            <a:pPr algn="ctr"/>
+            <a:r>
+              <a:rPr sz="1200" b="1">
+                <a:solidFill>
+                  <a:srgbClr val="FFFFFF"/>
+                </a:solidFill>
+              </a:rPr>
+              <a:t>EWE Engine</a:t>
+            </a:r>
+          </a:p>
+        </p:txBody>
+      </p:sp>
+      <p:sp>
+        <p:nvSpPr>
+          <p:cNvPr id="23" name="TextBox 22"/>
+          <p:cNvSpPr txBox="1"/>
+          <p:nvPr/>
+        </p:nvSpPr>
+        <p:spPr>
+          <a:xfrm>
+            <a:off x="4507992" y="2816352"/>
+            <a:ext cx="1426464" cy="594359"/>
+          </a:xfrm>
+          <a:prstGeom prst="rect">
+            <a:avLst/>
+          </a:prstGeom>
+          <a:noFill/>
+        </p:spPr>
+        <p:txBody>
+          <a:bodyPr wrap="square" lIns="36576" rIns="36576" tIns="18288" bIns="18288">
+            <a:spAutoFit/>
+          </a:bodyPr>
+          <a:lstStyle/>
+          <a:p>
+            <a:pPr algn="ctr"/>
+            <a:r>
+              <a:rPr sz="850" b="0">
+                <a:solidFill>
+                  <a:srgbClr val="FFFFFF"/>
+                </a:solidFill>
+              </a:rPr>
+              <a:t>Element-wise ops
+add / mul / sub
+activation / compare</a:t>
+            </a:r>
+          </a:p>
+        </p:txBody>
+      </p:sp>
+      <p:sp>
+        <p:nvSpPr>
+          <p:cNvPr id="24" name="Rounded Rectangle 23"/>
+          <p:cNvSpPr/>
+          <p:nvPr/>
+        </p:nvSpPr>
+        <p:spPr>
+          <a:xfrm>
+            <a:off x="6300216" y="2423160"/>
+            <a:ext cx="1645920" cy="1051560"/>
+          </a:xfrm>
+          <a:prstGeom prst="roundRect">
+            <a:avLst/>
+          </a:prstGeom>
+          <a:solidFill>
+            <a:srgbClr val="F0C656"/>
+          </a:solidFill>
+          <a:ln>
+            <a:solidFill>
+              <a:srgbClr val="F0C656"/>
+            </a:solidFill>
+          </a:ln>
+        </p:spPr>
+        <p:style>
+          <a:lnRef idx="1">
+            <a:schemeClr val="accent1"/>
+          </a:lnRef>
+          <a:fillRef idx="3">
+            <a:schemeClr val="accent1"/>
+          </a:fillRef>
+          <a:effectRef idx="2">
+            <a:schemeClr val="accent1"/>
+          </a:effectRef>
+          <a:fontRef idx="minor">
+            <a:schemeClr val="lt1"/>
+          </a:fontRef>
+        </p:style>
+        <p:txBody>
+          <a:bodyPr rtlCol="0" anchor="ctr"/>
+          <a:lstStyle/>
+          <a:p>
+            <a:pPr algn="ctr"/>
+          </a:p>
+        </p:txBody>
+      </p:sp>
+      <p:sp>
+        <p:nvSpPr>
+          <p:cNvPr id="25" name="TextBox 24"/>
+          <p:cNvSpPr txBox="1"/>
+          <p:nvPr/>
+        </p:nvSpPr>
+        <p:spPr>
+          <a:xfrm>
+            <a:off x="6373368" y="2532888"/>
+            <a:ext cx="1499616" cy="228600"/>
+          </a:xfrm>
+          <a:prstGeom prst="rect">
+            <a:avLst/>
+          </a:prstGeom>
+          <a:noFill/>
+        </p:spPr>
+        <p:txBody>
+          <a:bodyPr wrap="square" lIns="36576" rIns="36576" tIns="18288" bIns="18288">
+            <a:spAutoFit/>
+          </a:bodyPr>
+          <a:lstStyle/>
+          <a:p>
+            <a:pPr algn="ctr"/>
+            <a:r>
+              <a:rPr sz="1200" b="1">
+                <a:solidFill>
+                  <a:srgbClr val="FFFFFF"/>
+                </a:solidFill>
+              </a:rPr>
+              <a:t>POOL Engine</a:t>
+            </a:r>
+          </a:p>
+        </p:txBody>
+      </p:sp>
+      <p:sp>
+        <p:nvSpPr>
+          <p:cNvPr id="26" name="TextBox 25"/>
+          <p:cNvSpPr txBox="1"/>
+          <p:nvPr/>
+        </p:nvSpPr>
+        <p:spPr>
+          <a:xfrm>
+            <a:off x="6409944" y="2816352"/>
+            <a:ext cx="1426464" cy="594359"/>
+          </a:xfrm>
+          <a:prstGeom prst="rect">
+            <a:avLst/>
+          </a:prstGeom>
+          <a:noFill/>
+        </p:spPr>
+        <p:txBody>
+          <a:bodyPr wrap="square" lIns="36576" rIns="36576" tIns="18288" bIns="18288">
+            <a:spAutoFit/>
+          </a:bodyPr>
+          <a:lstStyle/>
+          <a:p>
+            <a:pPr algn="ctr"/>
+            <a:r>
+              <a:rPr sz="850" b="0">
+                <a:solidFill>
+                  <a:srgbClr val="FFFFFF"/>
+                </a:solidFill>
+              </a:rPr>
+              <a:t>Max / Avg / Global
+spatial reduction
+window ops</a:t>
+            </a:r>
+          </a:p>
+        </p:txBody>
+      </p:sp>
+      <p:sp>
+        <p:nvSpPr>
+          <p:cNvPr id="27" name="Rounded Rectangle 26"/>
+          <p:cNvSpPr/>
+          <p:nvPr/>
+        </p:nvSpPr>
+        <p:spPr>
+          <a:xfrm>
+            <a:off x="8202168" y="2423160"/>
+            <a:ext cx="1645920" cy="1051560"/>
+          </a:xfrm>
+          <a:prstGeom prst="roundRect">
+            <a:avLst/>
+          </a:prstGeom>
+          <a:solidFill>
+            <a:srgbClr val="B84141"/>
+          </a:solidFill>
+          <a:ln>
+            <a:solidFill>
+              <a:srgbClr val="B84141"/>
+            </a:solidFill>
+          </a:ln>
+        </p:spPr>
+        <p:style>
+          <a:lnRef idx="1">
+            <a:schemeClr val="accent1"/>
+          </a:lnRef>
+          <a:fillRef idx="3">
+            <a:schemeClr val="accent1"/>
+          </a:fillRef>
+          <a:effectRef idx="2">
+            <a:schemeClr val="accent1"/>
+          </a:effectRef>
+          <a:fontRef idx="minor">
+            <a:schemeClr val="lt1"/>
+          </a:fontRef>
+        </p:style>
+        <p:txBody>
+          <a:bodyPr rtlCol="0" anchor="ctr"/>
+          <a:lstStyle/>
+          <a:p>
+            <a:pPr algn="ctr"/>
+          </a:p>
+        </p:txBody>
+      </p:sp>
+      <p:sp>
+        <p:nvSpPr>
+          <p:cNvPr id="28" name="TextBox 27"/>
+          <p:cNvSpPr txBox="1"/>
+          <p:nvPr/>
+        </p:nvSpPr>
+        <p:spPr>
+          <a:xfrm>
+            <a:off x="8275320" y="2532888"/>
+            <a:ext cx="1499616" cy="228600"/>
+          </a:xfrm>
+          <a:prstGeom prst="rect">
+            <a:avLst/>
+          </a:prstGeom>
+          <a:noFill/>
+        </p:spPr>
+        <p:txBody>
+          <a:bodyPr wrap="square" lIns="36576" rIns="36576" tIns="18288" bIns="18288">
+            <a:spAutoFit/>
+          </a:bodyPr>
+          <a:lstStyle/>
+          <a:p>
+            <a:pPr algn="ctr"/>
+            <a:r>
+              <a:rPr sz="1200" b="1">
+                <a:solidFill>
+                  <a:srgbClr val="FFFFFF"/>
+                </a:solidFill>
+              </a:rPr>
+              <a:t>TNPS Engine</a:t>
+            </a:r>
+          </a:p>
+        </p:txBody>
+      </p:sp>
+      <p:sp>
+        <p:nvSpPr>
+          <p:cNvPr id="29" name="TextBox 28"/>
+          <p:cNvSpPr txBox="1"/>
+          <p:nvPr/>
+        </p:nvSpPr>
+        <p:spPr>
+          <a:xfrm>
+            <a:off x="8311896" y="2816352"/>
+            <a:ext cx="1426464" cy="594359"/>
+          </a:xfrm>
+          <a:prstGeom prst="rect">
+            <a:avLst/>
+          </a:prstGeom>
+          <a:noFill/>
+        </p:spPr>
+        <p:txBody>
+          <a:bodyPr wrap="square" lIns="36576" rIns="36576" tIns="18288" bIns="18288">
+            <a:spAutoFit/>
+          </a:bodyPr>
+          <a:lstStyle/>
+          <a:p>
+            <a:pPr algn="ctr"/>
+            <a:r>
+              <a:rPr sz="850" b="0">
+                <a:solidFill>
+                  <a:srgbClr val="FFFFFF"/>
+                </a:solidFill>
+              </a:rPr>
+              <a:t>transpose / slice
+space-depth / layout
+L1-to-L1 movement</a:t>
+            </a:r>
+          </a:p>
+        </p:txBody>
+      </p:sp>
+      <p:cxnSp>
+        <p:nvCxnSpPr>
+          <p:cNvPr id="30" name="Connector 29"/>
+          <p:cNvCxnSpPr/>
+          <p:nvPr/>
+        </p:nvCxnSpPr>
+        <p:spPr>
+          <a:xfrm>
+            <a:off x="1417320" y="2011680"/>
+            <a:ext cx="0" cy="411480"/>
+          </a:xfrm>
+          <a:prstGeom prst="line">
+            <a:avLst/>
+          </a:prstGeom>
+          <a:ln w="13970">
+            <a:solidFill>
+              <a:srgbClr val="5E6875"/>
+            </a:solidFill>
+            <a:prstDash val="dash"/>
+          </a:ln>
+        </p:spPr>
+        <p:style>
+          <a:lnRef idx="2">
+            <a:schemeClr val="accent1"/>
+          </a:lnRef>
+          <a:fillRef idx="0">
+            <a:schemeClr val="accent1"/>
+          </a:fillRef>
+          <a:effectRef idx="1">
+            <a:schemeClr val="accent1"/>
+          </a:effectRef>
+          <a:fontRef idx="minor">
+            <a:schemeClr val="tx1"/>
+          </a:fontRef>
+        </p:style>
+      </p:cxnSp>
+      <p:sp>
+        <p:nvSpPr>
+          <p:cNvPr id="31" name="TextBox 30"/>
+          <p:cNvSpPr txBox="1"/>
+          <p:nvPr/>
+        </p:nvSpPr>
+        <p:spPr>
+          <a:xfrm>
+            <a:off x="1188720" y="2157984"/>
+            <a:ext cx="457200" cy="182880"/>
+          </a:xfrm>
+          <a:prstGeom prst="rect">
+            <a:avLst/>
+          </a:prstGeom>
+          <a:noFill/>
+        </p:spPr>
+        <p:txBody>
+          <a:bodyPr wrap="square" lIns="36576" rIns="36576" tIns="18288" bIns="18288">
+            <a:spAutoFit/>
+          </a:bodyPr>
+          <a:lstStyle/>
+          <a:p>
+            <a:pPr algn="ctr"/>
+            <a:r>
+              <a:rPr sz="750" b="1">
                 <a:solidFill>
                   <a:srgbClr val="5E6875"/>
                 </a:solidFill>
               </a:rPr>
-              <a:t>→</a:t>
-            </a:r>
-          </a:p>
-        </p:txBody>
-      </p:sp>
-      <p:sp>
-        <p:nvSpPr>
-          <p:cNvPr id="15" name="TextBox 14"/>
-          <p:cNvSpPr txBox="1"/>
-          <p:nvPr/>
-        </p:nvSpPr>
-        <p:spPr>
-          <a:xfrm>
-            <a:off x="3429000" y="2999232"/>
-            <a:ext cx="411480" cy="274320"/>
-          </a:xfrm>
-          <a:prstGeom prst="rect">
-            <a:avLst/>
-          </a:prstGeom>
-          <a:noFill/>
-        </p:spPr>
-        <p:txBody>
-          <a:bodyPr wrap="square" lIns="36576" rIns="36576" tIns="18288" bIns="18288">
-            <a:spAutoFit/>
-          </a:bodyPr>
-          <a:lstStyle/>
-          <a:p>
-            <a:pPr algn="ctr"/>
-            <a:r>
-              <a:rPr sz="2000" b="1">
+              <a:t>W 1T</a:t>
+            </a:r>
+          </a:p>
+        </p:txBody>
+      </p:sp>
+      <p:cxnSp>
+        <p:nvCxnSpPr>
+          <p:cNvPr id="32" name="Connector 31"/>
+          <p:cNvCxnSpPr/>
+          <p:nvPr/>
+        </p:nvCxnSpPr>
+        <p:spPr>
+          <a:xfrm>
+            <a:off x="3319272" y="2011680"/>
+            <a:ext cx="0" cy="411480"/>
+          </a:xfrm>
+          <a:prstGeom prst="line">
+            <a:avLst/>
+          </a:prstGeom>
+          <a:ln w="13970">
+            <a:solidFill>
+              <a:srgbClr val="5E6875"/>
+            </a:solidFill>
+            <a:prstDash val="dash"/>
+          </a:ln>
+        </p:spPr>
+        <p:style>
+          <a:lnRef idx="2">
+            <a:schemeClr val="accent1"/>
+          </a:lnRef>
+          <a:fillRef idx="0">
+            <a:schemeClr val="accent1"/>
+          </a:fillRef>
+          <a:effectRef idx="1">
+            <a:schemeClr val="accent1"/>
+          </a:effectRef>
+          <a:fontRef idx="minor">
+            <a:schemeClr val="tx1"/>
+          </a:fontRef>
+        </p:style>
+      </p:cxnSp>
+      <p:sp>
+        <p:nvSpPr>
+          <p:cNvPr id="33" name="TextBox 32"/>
+          <p:cNvSpPr txBox="1"/>
+          <p:nvPr/>
+        </p:nvSpPr>
+        <p:spPr>
+          <a:xfrm>
+            <a:off x="3090672" y="2157984"/>
+            <a:ext cx="457200" cy="182880"/>
+          </a:xfrm>
+          <a:prstGeom prst="rect">
+            <a:avLst/>
+          </a:prstGeom>
+          <a:noFill/>
+        </p:spPr>
+        <p:txBody>
+          <a:bodyPr wrap="square" lIns="36576" rIns="36576" tIns="18288" bIns="18288">
+            <a:spAutoFit/>
+          </a:bodyPr>
+          <a:lstStyle/>
+          <a:p>
+            <a:pPr algn="ctr"/>
+            <a:r>
+              <a:rPr sz="750" b="1">
                 <a:solidFill>
                   <a:srgbClr val="5E6875"/>
                 </a:solidFill>
               </a:rPr>
-              <a:t>→</a:t>
-            </a:r>
-          </a:p>
-        </p:txBody>
-      </p:sp>
-      <p:sp>
-        <p:nvSpPr>
-          <p:cNvPr id="16" name="TextBox 15"/>
-          <p:cNvSpPr txBox="1"/>
-          <p:nvPr/>
-        </p:nvSpPr>
-        <p:spPr>
-          <a:xfrm>
-            <a:off x="4983480" y="2999232"/>
-            <a:ext cx="411480" cy="274320"/>
-          </a:xfrm>
-          <a:prstGeom prst="rect">
-            <a:avLst/>
-          </a:prstGeom>
-          <a:noFill/>
-        </p:spPr>
-        <p:txBody>
-          <a:bodyPr wrap="square" lIns="36576" rIns="36576" tIns="18288" bIns="18288">
-            <a:spAutoFit/>
-          </a:bodyPr>
-          <a:lstStyle/>
-          <a:p>
-            <a:pPr algn="ctr"/>
-            <a:r>
-              <a:rPr sz="2000" b="1">
+              <a:t>W 1T</a:t>
+            </a:r>
+          </a:p>
+        </p:txBody>
+      </p:sp>
+      <p:cxnSp>
+        <p:nvCxnSpPr>
+          <p:cNvPr id="34" name="Connector 33"/>
+          <p:cNvCxnSpPr/>
+          <p:nvPr/>
+        </p:nvCxnSpPr>
+        <p:spPr>
+          <a:xfrm>
+            <a:off x="5221224" y="2011680"/>
+            <a:ext cx="0" cy="411480"/>
+          </a:xfrm>
+          <a:prstGeom prst="line">
+            <a:avLst/>
+          </a:prstGeom>
+          <a:ln w="13970">
+            <a:solidFill>
+              <a:srgbClr val="5E6875"/>
+            </a:solidFill>
+            <a:prstDash val="dash"/>
+          </a:ln>
+        </p:spPr>
+        <p:style>
+          <a:lnRef idx="2">
+            <a:schemeClr val="accent1"/>
+          </a:lnRef>
+          <a:fillRef idx="0">
+            <a:schemeClr val="accent1"/>
+          </a:fillRef>
+          <a:effectRef idx="1">
+            <a:schemeClr val="accent1"/>
+          </a:effectRef>
+          <a:fontRef idx="minor">
+            <a:schemeClr val="tx1"/>
+          </a:fontRef>
+        </p:style>
+      </p:cxnSp>
+      <p:sp>
+        <p:nvSpPr>
+          <p:cNvPr id="35" name="TextBox 34"/>
+          <p:cNvSpPr txBox="1"/>
+          <p:nvPr/>
+        </p:nvSpPr>
+        <p:spPr>
+          <a:xfrm>
+            <a:off x="4992624" y="2157984"/>
+            <a:ext cx="457200" cy="182880"/>
+          </a:xfrm>
+          <a:prstGeom prst="rect">
+            <a:avLst/>
+          </a:prstGeom>
+          <a:noFill/>
+        </p:spPr>
+        <p:txBody>
+          <a:bodyPr wrap="square" lIns="36576" rIns="36576" tIns="18288" bIns="18288">
+            <a:spAutoFit/>
+          </a:bodyPr>
+          <a:lstStyle/>
+          <a:p>
+            <a:pPr algn="ctr"/>
+            <a:r>
+              <a:rPr sz="750" b="1">
                 <a:solidFill>
                   <a:srgbClr val="5E6875"/>
                 </a:solidFill>
               </a:rPr>
-              <a:t>→</a:t>
-            </a:r>
-          </a:p>
-        </p:txBody>
-      </p:sp>
-      <p:sp>
-        <p:nvSpPr>
-          <p:cNvPr id="17" name="TextBox 16"/>
-          <p:cNvSpPr txBox="1"/>
-          <p:nvPr/>
-        </p:nvSpPr>
-        <p:spPr>
-          <a:xfrm>
-            <a:off x="6812280" y="2999232"/>
-            <a:ext cx="411480" cy="274320"/>
-          </a:xfrm>
-          <a:prstGeom prst="rect">
-            <a:avLst/>
-          </a:prstGeom>
-          <a:noFill/>
-        </p:spPr>
-        <p:txBody>
-          <a:bodyPr wrap="square" lIns="36576" rIns="36576" tIns="18288" bIns="18288">
-            <a:spAutoFit/>
-          </a:bodyPr>
-          <a:lstStyle/>
-          <a:p>
-            <a:pPr algn="ctr"/>
-            <a:r>
-              <a:rPr sz="2000" b="1">
+              <a:t>W 1T</a:t>
+            </a:r>
+          </a:p>
+        </p:txBody>
+      </p:sp>
+      <p:cxnSp>
+        <p:nvCxnSpPr>
+          <p:cNvPr id="36" name="Connector 35"/>
+          <p:cNvCxnSpPr/>
+          <p:nvPr/>
+        </p:nvCxnSpPr>
+        <p:spPr>
+          <a:xfrm>
+            <a:off x="7123176" y="2011680"/>
+            <a:ext cx="0" cy="411480"/>
+          </a:xfrm>
+          <a:prstGeom prst="line">
+            <a:avLst/>
+          </a:prstGeom>
+          <a:ln w="13970">
+            <a:solidFill>
+              <a:srgbClr val="5E6875"/>
+            </a:solidFill>
+            <a:prstDash val="dash"/>
+          </a:ln>
+        </p:spPr>
+        <p:style>
+          <a:lnRef idx="2">
+            <a:schemeClr val="accent1"/>
+          </a:lnRef>
+          <a:fillRef idx="0">
+            <a:schemeClr val="accent1"/>
+          </a:fillRef>
+          <a:effectRef idx="1">
+            <a:schemeClr val="accent1"/>
+          </a:effectRef>
+          <a:fontRef idx="minor">
+            <a:schemeClr val="tx1"/>
+          </a:fontRef>
+        </p:style>
+      </p:cxnSp>
+      <p:sp>
+        <p:nvSpPr>
+          <p:cNvPr id="37" name="TextBox 36"/>
+          <p:cNvSpPr txBox="1"/>
+          <p:nvPr/>
+        </p:nvSpPr>
+        <p:spPr>
+          <a:xfrm>
+            <a:off x="6894576" y="2157984"/>
+            <a:ext cx="457200" cy="182880"/>
+          </a:xfrm>
+          <a:prstGeom prst="rect">
+            <a:avLst/>
+          </a:prstGeom>
+          <a:noFill/>
+        </p:spPr>
+        <p:txBody>
+          <a:bodyPr wrap="square" lIns="36576" rIns="36576" tIns="18288" bIns="18288">
+            <a:spAutoFit/>
+          </a:bodyPr>
+          <a:lstStyle/>
+          <a:p>
+            <a:pPr algn="ctr"/>
+            <a:r>
+              <a:rPr sz="750" b="1">
                 <a:solidFill>
                   <a:srgbClr val="5E6875"/>
                 </a:solidFill>
               </a:rPr>
-              <a:t>→</a:t>
-            </a:r>
-          </a:p>
-        </p:txBody>
-      </p:sp>
-      <p:sp>
-        <p:nvSpPr>
-          <p:cNvPr id="18" name="TextBox 17"/>
-          <p:cNvSpPr txBox="1"/>
-          <p:nvPr/>
-        </p:nvSpPr>
-        <p:spPr>
-          <a:xfrm>
-            <a:off x="713232" y="4892040"/>
-            <a:ext cx="6675120" cy="292608"/>
-          </a:xfrm>
-          <a:prstGeom prst="rect">
-            <a:avLst/>
-          </a:prstGeom>
-          <a:noFill/>
-        </p:spPr>
-        <p:txBody>
-          <a:bodyPr wrap="square" lIns="36576" rIns="36576" tIns="18288" bIns="18288">
-            <a:spAutoFit/>
-          </a:bodyPr>
-          <a:lstStyle/>
-          <a:p>
-            <a:r>
-              <a:rPr sz="1200" b="0">
+              <a:t>W 1T</a:t>
+            </a:r>
+          </a:p>
+        </p:txBody>
+      </p:sp>
+      <p:cxnSp>
+        <p:nvCxnSpPr>
+          <p:cNvPr id="38" name="Connector 37"/>
+          <p:cNvCxnSpPr/>
+          <p:nvPr/>
+        </p:nvCxnSpPr>
+        <p:spPr>
+          <a:xfrm>
+            <a:off x="9025128" y="2011680"/>
+            <a:ext cx="0" cy="411480"/>
+          </a:xfrm>
+          <a:prstGeom prst="line">
+            <a:avLst/>
+          </a:prstGeom>
+          <a:ln w="13970">
+            <a:solidFill>
+              <a:srgbClr val="5E6875"/>
+            </a:solidFill>
+            <a:prstDash val="dash"/>
+          </a:ln>
+        </p:spPr>
+        <p:style>
+          <a:lnRef idx="2">
+            <a:schemeClr val="accent1"/>
+          </a:lnRef>
+          <a:fillRef idx="0">
+            <a:schemeClr val="accent1"/>
+          </a:fillRef>
+          <a:effectRef idx="1">
+            <a:schemeClr val="accent1"/>
+          </a:effectRef>
+          <a:fontRef idx="minor">
+            <a:schemeClr val="tx1"/>
+          </a:fontRef>
+        </p:style>
+      </p:cxnSp>
+      <p:sp>
+        <p:nvSpPr>
+          <p:cNvPr id="39" name="TextBox 38"/>
+          <p:cNvSpPr txBox="1"/>
+          <p:nvPr/>
+        </p:nvSpPr>
+        <p:spPr>
+          <a:xfrm>
+            <a:off x="8796528" y="2157984"/>
+            <a:ext cx="457200" cy="182880"/>
+          </a:xfrm>
+          <a:prstGeom prst="rect">
+            <a:avLst/>
+          </a:prstGeom>
+          <a:noFill/>
+        </p:spPr>
+        <p:txBody>
+          <a:bodyPr wrap="square" lIns="36576" rIns="36576" tIns="18288" bIns="18288">
+            <a:spAutoFit/>
+          </a:bodyPr>
+          <a:lstStyle/>
+          <a:p>
+            <a:pPr algn="ctr"/>
+            <a:r>
+              <a:rPr sz="750" b="1">
                 <a:solidFill>
                   <a:srgbClr val="5E6875"/>
                 </a:solidFill>
               </a:rPr>
-              <a:t>Prepared from the current MDLA7_Codex repository and regression reports</a:t>
-            </a:r>
-          </a:p>
-        </p:txBody>
-      </p:sp>
-      <p:sp>
-        <p:nvSpPr>
-          <p:cNvPr id="19" name="TextBox 18"/>
-          <p:cNvSpPr txBox="1"/>
-          <p:nvPr/>
-        </p:nvSpPr>
-        <p:spPr>
-          <a:xfrm>
-            <a:off x="713232" y="5257800"/>
-            <a:ext cx="3657600" cy="292608"/>
-          </a:xfrm>
-          <a:prstGeom prst="rect">
-            <a:avLst/>
-          </a:prstGeom>
-          <a:noFill/>
-        </p:spPr>
-        <p:txBody>
-          <a:bodyPr wrap="square" lIns="36576" rIns="36576" tIns="18288" bIns="18288">
-            <a:spAutoFit/>
-          </a:bodyPr>
-          <a:lstStyle/>
-          <a:p>
-            <a:r>
-              <a:rPr sz="1100" b="0">
+              <a:t>W 1T</a:t>
+            </a:r>
+          </a:p>
+        </p:txBody>
+      </p:sp>
+      <p:sp>
+        <p:nvSpPr>
+          <p:cNvPr id="40" name="Rounded Rectangle 39"/>
+          <p:cNvSpPr/>
+          <p:nvPr/>
+        </p:nvSpPr>
+        <p:spPr>
+          <a:xfrm>
+            <a:off x="594360" y="4160520"/>
+            <a:ext cx="1645920" cy="713232"/>
+          </a:xfrm>
+          <a:prstGeom prst="roundRect">
+            <a:avLst/>
+          </a:prstGeom>
+          <a:solidFill>
+            <a:srgbClr val="B84141"/>
+          </a:solidFill>
+          <a:ln>
+            <a:solidFill>
+              <a:srgbClr val="B84141"/>
+            </a:solidFill>
+          </a:ln>
+        </p:spPr>
+        <p:style>
+          <a:lnRef idx="1">
+            <a:schemeClr val="accent1"/>
+          </a:lnRef>
+          <a:fillRef idx="3">
+            <a:schemeClr val="accent1"/>
+          </a:fillRef>
+          <a:effectRef idx="2">
+            <a:schemeClr val="accent1"/>
+          </a:effectRef>
+          <a:fontRef idx="minor">
+            <a:schemeClr val="lt1"/>
+          </a:fontRef>
+        </p:style>
+        <p:txBody>
+          <a:bodyPr rtlCol="0" anchor="ctr"/>
+          <a:lstStyle/>
+          <a:p>
+            <a:pPr algn="ctr"/>
+          </a:p>
+        </p:txBody>
+      </p:sp>
+      <p:sp>
+        <p:nvSpPr>
+          <p:cNvPr id="41" name="TextBox 40"/>
+          <p:cNvSpPr txBox="1"/>
+          <p:nvPr/>
+        </p:nvSpPr>
+        <p:spPr>
+          <a:xfrm>
+            <a:off x="667512" y="4270248"/>
+            <a:ext cx="1499616" cy="228600"/>
+          </a:xfrm>
+          <a:prstGeom prst="rect">
+            <a:avLst/>
+          </a:prstGeom>
+          <a:noFill/>
+        </p:spPr>
+        <p:txBody>
+          <a:bodyPr wrap="square" lIns="36576" rIns="36576" tIns="18288" bIns="18288">
+            <a:spAutoFit/>
+          </a:bodyPr>
+          <a:lstStyle/>
+          <a:p>
+            <a:pPr algn="ctr"/>
+            <a:r>
+              <a:rPr sz="1200" b="1">
+                <a:solidFill>
+                  <a:srgbClr val="FFFFFF"/>
+                </a:solidFill>
+              </a:rPr>
+              <a:t>L1Mesh</a:t>
+            </a:r>
+          </a:p>
+        </p:txBody>
+      </p:sp>
+      <p:sp>
+        <p:nvSpPr>
+          <p:cNvPr id="42" name="TextBox 41"/>
+          <p:cNvSpPr txBox="1"/>
+          <p:nvPr/>
+        </p:nvSpPr>
+        <p:spPr>
+          <a:xfrm>
+            <a:off x="704088" y="4553712"/>
+            <a:ext cx="1426464" cy="256032"/>
+          </a:xfrm>
+          <a:prstGeom prst="rect">
+            <a:avLst/>
+          </a:prstGeom>
+          <a:noFill/>
+        </p:spPr>
+        <p:txBody>
+          <a:bodyPr wrap="square" lIns="36576" rIns="36576" tIns="18288" bIns="18288">
+            <a:spAutoFit/>
+          </a:bodyPr>
+          <a:lstStyle/>
+          <a:p>
+            <a:pPr algn="ctr"/>
+            <a:r>
+              <a:rPr sz="850" b="0">
+                <a:solidFill>
+                  <a:srgbClr val="FFFFFF"/>
+                </a:solidFill>
+              </a:rPr>
+              <a:t>3 MB
+4x4 NoC SRAM</a:t>
+            </a:r>
+          </a:p>
+        </p:txBody>
+      </p:sp>
+      <p:sp>
+        <p:nvSpPr>
+          <p:cNvPr id="43" name="Rounded Rectangle 42"/>
+          <p:cNvSpPr/>
+          <p:nvPr/>
+        </p:nvSpPr>
+        <p:spPr>
+          <a:xfrm>
+            <a:off x="2606040" y="4160520"/>
+            <a:ext cx="8595360" cy="713232"/>
+          </a:xfrm>
+          <a:prstGeom prst="roundRect">
+            <a:avLst/>
+          </a:prstGeom>
+          <a:solidFill>
+            <a:srgbClr val="F0C656"/>
+          </a:solidFill>
+          <a:ln>
+            <a:solidFill>
+              <a:srgbClr val="F0C656"/>
+            </a:solidFill>
+          </a:ln>
+        </p:spPr>
+        <p:style>
+          <a:lnRef idx="1">
+            <a:schemeClr val="accent1"/>
+          </a:lnRef>
+          <a:fillRef idx="3">
+            <a:schemeClr val="accent1"/>
+          </a:fillRef>
+          <a:effectRef idx="2">
+            <a:schemeClr val="accent1"/>
+          </a:effectRef>
+          <a:fontRef idx="minor">
+            <a:schemeClr val="lt1"/>
+          </a:fontRef>
+        </p:style>
+        <p:txBody>
+          <a:bodyPr rtlCol="0" anchor="ctr"/>
+          <a:lstStyle/>
+          <a:p>
+            <a:pPr algn="ctr"/>
+          </a:p>
+        </p:txBody>
+      </p:sp>
+      <p:sp>
+        <p:nvSpPr>
+          <p:cNvPr id="44" name="TextBox 43"/>
+          <p:cNvSpPr txBox="1"/>
+          <p:nvPr/>
+        </p:nvSpPr>
+        <p:spPr>
+          <a:xfrm>
+            <a:off x="2679192" y="4270248"/>
+            <a:ext cx="8449056" cy="228600"/>
+          </a:xfrm>
+          <a:prstGeom prst="rect">
+            <a:avLst/>
+          </a:prstGeom>
+          <a:noFill/>
+        </p:spPr>
+        <p:txBody>
+          <a:bodyPr wrap="square" lIns="36576" rIns="36576" tIns="18288" bIns="18288">
+            <a:spAutoFit/>
+          </a:bodyPr>
+          <a:lstStyle/>
+          <a:p>
+            <a:pPr algn="ctr"/>
+            <a:r>
+              <a:rPr sz="1200" b="1">
+                <a:solidFill>
+                  <a:srgbClr val="FFFFFF"/>
+                </a:solidFill>
+              </a:rPr>
+              <a:t>L1_Manager</a:t>
+            </a:r>
+          </a:p>
+        </p:txBody>
+      </p:sp>
+      <p:sp>
+        <p:nvSpPr>
+          <p:cNvPr id="45" name="TextBox 44"/>
+          <p:cNvSpPr txBox="1"/>
+          <p:nvPr/>
+        </p:nvSpPr>
+        <p:spPr>
+          <a:xfrm>
+            <a:off x="2715768" y="4553712"/>
+            <a:ext cx="8375904" cy="256032"/>
+          </a:xfrm>
+          <a:prstGeom prst="rect">
+            <a:avLst/>
+          </a:prstGeom>
+          <a:noFill/>
+        </p:spPr>
+        <p:txBody>
+          <a:bodyPr wrap="square" lIns="36576" rIns="36576" tIns="18288" bIns="18288">
+            <a:spAutoFit/>
+          </a:bodyPr>
+          <a:lstStyle/>
+          <a:p>
+            <a:pPr algn="ctr"/>
+            <a:r>
+              <a:rPr sz="850" b="0">
+                <a:solidFill>
+                  <a:srgbClr val="FFFFFF"/>
+                </a:solidFill>
+              </a:rPr>
+              <a:t>Arbitrates non-CONV engines and UDMA; CONV ACT/WGT reads bypass directly to L1Mesh</a:t>
+            </a:r>
+          </a:p>
+        </p:txBody>
+      </p:sp>
+      <p:cxnSp>
+        <p:nvCxnSpPr>
+          <p:cNvPr id="46" name="Connector 45"/>
+          <p:cNvCxnSpPr/>
+          <p:nvPr/>
+        </p:nvCxnSpPr>
+        <p:spPr>
+          <a:xfrm flipV="1">
+            <a:off x="1325880" y="3474720"/>
+            <a:ext cx="0" cy="685800"/>
+          </a:xfrm>
+          <a:prstGeom prst="line">
+            <a:avLst/>
+          </a:prstGeom>
+          <a:ln w="31750">
+            <a:solidFill>
+              <a:srgbClr val="2E65B4"/>
+            </a:solidFill>
+          </a:ln>
+        </p:spPr>
+        <p:style>
+          <a:lnRef idx="2">
+            <a:schemeClr val="accent1"/>
+          </a:lnRef>
+          <a:fillRef idx="0">
+            <a:schemeClr val="accent1"/>
+          </a:fillRef>
+          <a:effectRef idx="1">
+            <a:schemeClr val="accent1"/>
+          </a:effectRef>
+          <a:fontRef idx="minor">
+            <a:schemeClr val="tx1"/>
+          </a:fontRef>
+        </p:style>
+      </p:cxnSp>
+      <p:sp>
+        <p:nvSpPr>
+          <p:cNvPr id="47" name="TextBox 46"/>
+          <p:cNvSpPr txBox="1"/>
+          <p:nvPr/>
+        </p:nvSpPr>
+        <p:spPr>
+          <a:xfrm>
+            <a:off x="658368" y="3657600"/>
+            <a:ext cx="1417320" cy="182880"/>
+          </a:xfrm>
+          <a:prstGeom prst="rect">
+            <a:avLst/>
+          </a:prstGeom>
+          <a:noFill/>
+        </p:spPr>
+        <p:txBody>
+          <a:bodyPr wrap="square" lIns="36576" rIns="36576" tIns="18288" bIns="18288">
+            <a:spAutoFit/>
+          </a:bodyPr>
+          <a:lstStyle/>
+          <a:p>
+            <a:pPr algn="ctr"/>
+            <a:r>
+              <a:rPr sz="750" b="1">
+                <a:solidFill>
+                  <a:srgbClr val="2E65B4"/>
+                </a:solidFill>
+              </a:rPr>
+              <a:t>32x16B R ACT</a:t>
+            </a:r>
+          </a:p>
+        </p:txBody>
+      </p:sp>
+      <p:cxnSp>
+        <p:nvCxnSpPr>
+          <p:cNvPr id="48" name="Connector 47"/>
+          <p:cNvCxnSpPr/>
+          <p:nvPr/>
+        </p:nvCxnSpPr>
+        <p:spPr>
+          <a:xfrm flipV="1">
+            <a:off x="1691640" y="3474720"/>
+            <a:ext cx="0" cy="685800"/>
+          </a:xfrm>
+          <a:prstGeom prst="line">
+            <a:avLst/>
+          </a:prstGeom>
+          <a:ln w="31750">
+            <a:solidFill>
+              <a:srgbClr val="2E65B4"/>
+            </a:solidFill>
+          </a:ln>
+        </p:spPr>
+        <p:style>
+          <a:lnRef idx="2">
+            <a:schemeClr val="accent1"/>
+          </a:lnRef>
+          <a:fillRef idx="0">
+            <a:schemeClr val="accent1"/>
+          </a:fillRef>
+          <a:effectRef idx="1">
+            <a:schemeClr val="accent1"/>
+          </a:effectRef>
+          <a:fontRef idx="minor">
+            <a:schemeClr val="tx1"/>
+          </a:fontRef>
+        </p:style>
+      </p:cxnSp>
+      <p:sp>
+        <p:nvSpPr>
+          <p:cNvPr id="49" name="TextBox 48"/>
+          <p:cNvSpPr txBox="1"/>
+          <p:nvPr/>
+        </p:nvSpPr>
+        <p:spPr>
+          <a:xfrm>
+            <a:off x="1499616" y="3858768"/>
+            <a:ext cx="1051560" cy="182880"/>
+          </a:xfrm>
+          <a:prstGeom prst="rect">
+            <a:avLst/>
+          </a:prstGeom>
+          <a:noFill/>
+        </p:spPr>
+        <p:txBody>
+          <a:bodyPr wrap="square" lIns="36576" rIns="36576" tIns="18288" bIns="18288">
+            <a:spAutoFit/>
+          </a:bodyPr>
+          <a:lstStyle/>
+          <a:p>
+            <a:pPr algn="ctr"/>
+            <a:r>
+              <a:rPr sz="750" b="1">
+                <a:solidFill>
+                  <a:srgbClr val="2E65B4"/>
+                </a:solidFill>
+              </a:rPr>
+              <a:t>32x16B R WGT</a:t>
+            </a:r>
+          </a:p>
+        </p:txBody>
+      </p:sp>
+      <p:cxnSp>
+        <p:nvCxnSpPr>
+          <p:cNvPr id="50" name="Connector 49"/>
+          <p:cNvCxnSpPr/>
+          <p:nvPr/>
+        </p:nvCxnSpPr>
+        <p:spPr>
+          <a:xfrm>
+            <a:off x="3319272" y="3474720"/>
+            <a:ext cx="0" cy="685800"/>
+          </a:xfrm>
+          <a:prstGeom prst="line">
+            <a:avLst/>
+          </a:prstGeom>
+          <a:ln w="26670">
+            <a:solidFill>
+              <a:srgbClr val="2E65B4"/>
+            </a:solidFill>
+          </a:ln>
+        </p:spPr>
+        <p:style>
+          <a:lnRef idx="2">
+            <a:schemeClr val="accent1"/>
+          </a:lnRef>
+          <a:fillRef idx="0">
+            <a:schemeClr val="accent1"/>
+          </a:fillRef>
+          <a:effectRef idx="1">
+            <a:schemeClr val="accent1"/>
+          </a:effectRef>
+          <a:fontRef idx="minor">
+            <a:schemeClr val="tx1"/>
+          </a:fontRef>
+        </p:style>
+      </p:cxnSp>
+      <p:sp>
+        <p:nvSpPr>
+          <p:cNvPr id="51" name="TextBox 50"/>
+          <p:cNvSpPr txBox="1"/>
+          <p:nvPr/>
+        </p:nvSpPr>
+        <p:spPr>
+          <a:xfrm>
+            <a:off x="2971800" y="3685032"/>
+            <a:ext cx="731520" cy="182880"/>
+          </a:xfrm>
+          <a:prstGeom prst="rect">
+            <a:avLst/>
+          </a:prstGeom>
+          <a:noFill/>
+        </p:spPr>
+        <p:txBody>
+          <a:bodyPr wrap="square" lIns="36576" rIns="36576" tIns="18288" bIns="18288">
+            <a:spAutoFit/>
+          </a:bodyPr>
+          <a:lstStyle/>
+          <a:p>
+            <a:pPr algn="ctr"/>
+            <a:r>
+              <a:rPr sz="750" b="1">
+                <a:solidFill>
+                  <a:srgbClr val="2E65B4"/>
+                </a:solidFill>
+              </a:rPr>
+              <a:t>8R/8W</a:t>
+            </a:r>
+          </a:p>
+        </p:txBody>
+      </p:sp>
+      <p:cxnSp>
+        <p:nvCxnSpPr>
+          <p:cNvPr id="52" name="Connector 51"/>
+          <p:cNvCxnSpPr/>
+          <p:nvPr/>
+        </p:nvCxnSpPr>
+        <p:spPr>
+          <a:xfrm>
+            <a:off x="5221224" y="3474720"/>
+            <a:ext cx="0" cy="685800"/>
+          </a:xfrm>
+          <a:prstGeom prst="line">
+            <a:avLst/>
+          </a:prstGeom>
+          <a:ln w="26670">
+            <a:solidFill>
+              <a:srgbClr val="2E65B4"/>
+            </a:solidFill>
+          </a:ln>
+        </p:spPr>
+        <p:style>
+          <a:lnRef idx="2">
+            <a:schemeClr val="accent1"/>
+          </a:lnRef>
+          <a:fillRef idx="0">
+            <a:schemeClr val="accent1"/>
+          </a:fillRef>
+          <a:effectRef idx="1">
+            <a:schemeClr val="accent1"/>
+          </a:effectRef>
+          <a:fontRef idx="minor">
+            <a:schemeClr val="tx1"/>
+          </a:fontRef>
+        </p:style>
+      </p:cxnSp>
+      <p:sp>
+        <p:nvSpPr>
+          <p:cNvPr id="53" name="TextBox 52"/>
+          <p:cNvSpPr txBox="1"/>
+          <p:nvPr/>
+        </p:nvSpPr>
+        <p:spPr>
+          <a:xfrm>
+            <a:off x="4873752" y="3685032"/>
+            <a:ext cx="731520" cy="182880"/>
+          </a:xfrm>
+          <a:prstGeom prst="rect">
+            <a:avLst/>
+          </a:prstGeom>
+          <a:noFill/>
+        </p:spPr>
+        <p:txBody>
+          <a:bodyPr wrap="square" lIns="36576" rIns="36576" tIns="18288" bIns="18288">
+            <a:spAutoFit/>
+          </a:bodyPr>
+          <a:lstStyle/>
+          <a:p>
+            <a:pPr algn="ctr"/>
+            <a:r>
+              <a:rPr sz="750" b="1">
+                <a:solidFill>
+                  <a:srgbClr val="2E65B4"/>
+                </a:solidFill>
+              </a:rPr>
+              <a:t>16R/8W</a:t>
+            </a:r>
+          </a:p>
+        </p:txBody>
+      </p:sp>
+      <p:cxnSp>
+        <p:nvCxnSpPr>
+          <p:cNvPr id="54" name="Connector 53"/>
+          <p:cNvCxnSpPr/>
+          <p:nvPr/>
+        </p:nvCxnSpPr>
+        <p:spPr>
+          <a:xfrm>
+            <a:off x="7123176" y="3474720"/>
+            <a:ext cx="0" cy="685800"/>
+          </a:xfrm>
+          <a:prstGeom prst="line">
+            <a:avLst/>
+          </a:prstGeom>
+          <a:ln w="26670">
+            <a:solidFill>
+              <a:srgbClr val="2E65B4"/>
+            </a:solidFill>
+          </a:ln>
+        </p:spPr>
+        <p:style>
+          <a:lnRef idx="2">
+            <a:schemeClr val="accent1"/>
+          </a:lnRef>
+          <a:fillRef idx="0">
+            <a:schemeClr val="accent1"/>
+          </a:fillRef>
+          <a:effectRef idx="1">
+            <a:schemeClr val="accent1"/>
+          </a:effectRef>
+          <a:fontRef idx="minor">
+            <a:schemeClr val="tx1"/>
+          </a:fontRef>
+        </p:style>
+      </p:cxnSp>
+      <p:sp>
+        <p:nvSpPr>
+          <p:cNvPr id="55" name="TextBox 54"/>
+          <p:cNvSpPr txBox="1"/>
+          <p:nvPr/>
+        </p:nvSpPr>
+        <p:spPr>
+          <a:xfrm>
+            <a:off x="6775704" y="3685032"/>
+            <a:ext cx="731520" cy="182880"/>
+          </a:xfrm>
+          <a:prstGeom prst="rect">
+            <a:avLst/>
+          </a:prstGeom>
+          <a:noFill/>
+        </p:spPr>
+        <p:txBody>
+          <a:bodyPr wrap="square" lIns="36576" rIns="36576" tIns="18288" bIns="18288">
+            <a:spAutoFit/>
+          </a:bodyPr>
+          <a:lstStyle/>
+          <a:p>
+            <a:pPr algn="ctr"/>
+            <a:r>
+              <a:rPr sz="750" b="1">
+                <a:solidFill>
+                  <a:srgbClr val="2E65B4"/>
+                </a:solidFill>
+              </a:rPr>
+              <a:t>16R/8W</a:t>
+            </a:r>
+          </a:p>
+        </p:txBody>
+      </p:sp>
+      <p:cxnSp>
+        <p:nvCxnSpPr>
+          <p:cNvPr id="56" name="Connector 55"/>
+          <p:cNvCxnSpPr/>
+          <p:nvPr/>
+        </p:nvCxnSpPr>
+        <p:spPr>
+          <a:xfrm>
+            <a:off x="9025128" y="3474720"/>
+            <a:ext cx="0" cy="685800"/>
+          </a:xfrm>
+          <a:prstGeom prst="line">
+            <a:avLst/>
+          </a:prstGeom>
+          <a:ln w="26670">
+            <a:solidFill>
+              <a:srgbClr val="2E65B4"/>
+            </a:solidFill>
+          </a:ln>
+        </p:spPr>
+        <p:style>
+          <a:lnRef idx="2">
+            <a:schemeClr val="accent1"/>
+          </a:lnRef>
+          <a:fillRef idx="0">
+            <a:schemeClr val="accent1"/>
+          </a:fillRef>
+          <a:effectRef idx="1">
+            <a:schemeClr val="accent1"/>
+          </a:effectRef>
+          <a:fontRef idx="minor">
+            <a:schemeClr val="tx1"/>
+          </a:fontRef>
+        </p:style>
+      </p:cxnSp>
+      <p:sp>
+        <p:nvSpPr>
+          <p:cNvPr id="57" name="TextBox 56"/>
+          <p:cNvSpPr txBox="1"/>
+          <p:nvPr/>
+        </p:nvSpPr>
+        <p:spPr>
+          <a:xfrm>
+            <a:off x="8677655" y="3685032"/>
+            <a:ext cx="731520" cy="182880"/>
+          </a:xfrm>
+          <a:prstGeom prst="rect">
+            <a:avLst/>
+          </a:prstGeom>
+          <a:noFill/>
+        </p:spPr>
+        <p:txBody>
+          <a:bodyPr wrap="square" lIns="36576" rIns="36576" tIns="18288" bIns="18288">
+            <a:spAutoFit/>
+          </a:bodyPr>
+          <a:lstStyle/>
+          <a:p>
+            <a:pPr algn="ctr"/>
+            <a:r>
+              <a:rPr sz="750" b="1">
+                <a:solidFill>
+                  <a:srgbClr val="2E65B4"/>
+                </a:solidFill>
+              </a:rPr>
+              <a:t>8R/8W</a:t>
+            </a:r>
+          </a:p>
+        </p:txBody>
+      </p:sp>
+      <p:cxnSp>
+        <p:nvCxnSpPr>
+          <p:cNvPr id="58" name="Connector 57"/>
+          <p:cNvCxnSpPr/>
+          <p:nvPr/>
+        </p:nvCxnSpPr>
+        <p:spPr>
+          <a:xfrm>
+            <a:off x="2240280" y="4517136"/>
+            <a:ext cx="365760" cy="0"/>
+          </a:xfrm>
+          <a:prstGeom prst="line">
+            <a:avLst/>
+          </a:prstGeom>
+          <a:ln w="26670">
+            <a:solidFill>
+              <a:srgbClr val="2E65B4"/>
+            </a:solidFill>
+          </a:ln>
+        </p:spPr>
+        <p:style>
+          <a:lnRef idx="2">
+            <a:schemeClr val="accent1"/>
+          </a:lnRef>
+          <a:fillRef idx="0">
+            <a:schemeClr val="accent1"/>
+          </a:fillRef>
+          <a:effectRef idx="1">
+            <a:schemeClr val="accent1"/>
+          </a:effectRef>
+          <a:fontRef idx="minor">
+            <a:schemeClr val="tx1"/>
+          </a:fontRef>
+        </p:style>
+      </p:cxnSp>
+      <p:sp>
+        <p:nvSpPr>
+          <p:cNvPr id="59" name="TextBox 58"/>
+          <p:cNvSpPr txBox="1"/>
+          <p:nvPr/>
+        </p:nvSpPr>
+        <p:spPr>
+          <a:xfrm>
+            <a:off x="2148840" y="4681728"/>
+            <a:ext cx="731520" cy="182880"/>
+          </a:xfrm>
+          <a:prstGeom prst="rect">
+            <a:avLst/>
+          </a:prstGeom>
+          <a:noFill/>
+        </p:spPr>
+        <p:txBody>
+          <a:bodyPr wrap="square" lIns="36576" rIns="36576" tIns="18288" bIns="18288">
+            <a:spAutoFit/>
+          </a:bodyPr>
+          <a:lstStyle/>
+          <a:p>
+            <a:pPr algn="ctr"/>
+            <a:r>
+              <a:rPr sz="750" b="1">
+                <a:solidFill>
+                  <a:srgbClr val="2E65B4"/>
+                </a:solidFill>
+              </a:rPr>
+              <a:t>16R/16W</a:t>
+            </a:r>
+          </a:p>
+        </p:txBody>
+      </p:sp>
+      <p:sp>
+        <p:nvSpPr>
+          <p:cNvPr id="60" name="Rounded Rectangle 59"/>
+          <p:cNvSpPr/>
+          <p:nvPr/>
+        </p:nvSpPr>
+        <p:spPr>
+          <a:xfrm>
+            <a:off x="2606040" y="5285232"/>
+            <a:ext cx="8595360" cy="566928"/>
+          </a:xfrm>
+          <a:prstGeom prst="roundRect">
+            <a:avLst/>
+          </a:prstGeom>
+          <a:solidFill>
+            <a:srgbClr val="7E5792"/>
+          </a:solidFill>
+          <a:ln>
+            <a:solidFill>
+              <a:srgbClr val="7E5792"/>
+            </a:solidFill>
+          </a:ln>
+        </p:spPr>
+        <p:style>
+          <a:lnRef idx="1">
+            <a:schemeClr val="accent1"/>
+          </a:lnRef>
+          <a:fillRef idx="3">
+            <a:schemeClr val="accent1"/>
+          </a:fillRef>
+          <a:effectRef idx="2">
+            <a:schemeClr val="accent1"/>
+          </a:effectRef>
+          <a:fontRef idx="minor">
+            <a:schemeClr val="lt1"/>
+          </a:fontRef>
+        </p:style>
+        <p:txBody>
+          <a:bodyPr rtlCol="0" anchor="ctr"/>
+          <a:lstStyle/>
+          <a:p>
+            <a:pPr algn="ctr"/>
+          </a:p>
+        </p:txBody>
+      </p:sp>
+      <p:sp>
+        <p:nvSpPr>
+          <p:cNvPr id="61" name="TextBox 60"/>
+          <p:cNvSpPr txBox="1"/>
+          <p:nvPr/>
+        </p:nvSpPr>
+        <p:spPr>
+          <a:xfrm>
+            <a:off x="2679192" y="5394960"/>
+            <a:ext cx="8449056" cy="228600"/>
+          </a:xfrm>
+          <a:prstGeom prst="rect">
+            <a:avLst/>
+          </a:prstGeom>
+          <a:noFill/>
+        </p:spPr>
+        <p:txBody>
+          <a:bodyPr wrap="square" lIns="36576" rIns="36576" tIns="18288" bIns="18288">
+            <a:spAutoFit/>
+          </a:bodyPr>
+          <a:lstStyle/>
+          <a:p>
+            <a:pPr algn="ctr"/>
+            <a:r>
+              <a:rPr sz="1200" b="1">
+                <a:solidFill>
+                  <a:srgbClr val="FFFFFF"/>
+                </a:solidFill>
+              </a:rPr>
+              <a:t>UDMA</a:t>
+            </a:r>
+          </a:p>
+        </p:txBody>
+      </p:sp>
+      <p:sp>
+        <p:nvSpPr>
+          <p:cNvPr id="62" name="TextBox 61"/>
+          <p:cNvSpPr txBox="1"/>
+          <p:nvPr/>
+        </p:nvSpPr>
+        <p:spPr>
+          <a:xfrm>
+            <a:off x="2715768" y="5678424"/>
+            <a:ext cx="8375904" cy="109728"/>
+          </a:xfrm>
+          <a:prstGeom prst="rect">
+            <a:avLst/>
+          </a:prstGeom>
+          <a:noFill/>
+        </p:spPr>
+        <p:txBody>
+          <a:bodyPr wrap="square" lIns="36576" rIns="36576" tIns="18288" bIns="18288">
+            <a:spAutoFit/>
+          </a:bodyPr>
+          <a:lstStyle/>
+          <a:p>
+            <a:pPr algn="ctr"/>
+            <a:r>
+              <a:rPr sz="850" b="0">
+                <a:solidFill>
+                  <a:srgbClr val="FFFFFF"/>
+                </a:solidFill>
+              </a:rPr>
+              <a:t>DRAM &lt;-&gt; L1 copy, prefetch/store, activation codec; layout ops moved to TNPS</a:t>
+            </a:r>
+          </a:p>
+        </p:txBody>
+      </p:sp>
+      <p:cxnSp>
+        <p:nvCxnSpPr>
+          <p:cNvPr id="63" name="Connector 62"/>
+          <p:cNvCxnSpPr/>
+          <p:nvPr/>
+        </p:nvCxnSpPr>
+        <p:spPr>
+          <a:xfrm>
+            <a:off x="6903720" y="4873752"/>
+            <a:ext cx="0" cy="411480"/>
+          </a:xfrm>
+          <a:prstGeom prst="line">
+            <a:avLst/>
+          </a:prstGeom>
+          <a:ln w="26670">
+            <a:solidFill>
+              <a:srgbClr val="2E65B4"/>
+            </a:solidFill>
+          </a:ln>
+        </p:spPr>
+        <p:style>
+          <a:lnRef idx="2">
+            <a:schemeClr val="accent1"/>
+          </a:lnRef>
+          <a:fillRef idx="0">
+            <a:schemeClr val="accent1"/>
+          </a:fillRef>
+          <a:effectRef idx="1">
+            <a:schemeClr val="accent1"/>
+          </a:effectRef>
+          <a:fontRef idx="minor">
+            <a:schemeClr val="tx1"/>
+          </a:fontRef>
+        </p:style>
+      </p:cxnSp>
+      <p:sp>
+        <p:nvSpPr>
+          <p:cNvPr id="64" name="TextBox 63"/>
+          <p:cNvSpPr txBox="1"/>
+          <p:nvPr/>
+        </p:nvSpPr>
+        <p:spPr>
+          <a:xfrm>
+            <a:off x="6537960" y="4983480"/>
+            <a:ext cx="731520" cy="182880"/>
+          </a:xfrm>
+          <a:prstGeom prst="rect">
+            <a:avLst/>
+          </a:prstGeom>
+          <a:noFill/>
+        </p:spPr>
+        <p:txBody>
+          <a:bodyPr wrap="square" lIns="36576" rIns="36576" tIns="18288" bIns="18288">
+            <a:spAutoFit/>
+          </a:bodyPr>
+          <a:lstStyle/>
+          <a:p>
+            <a:pPr algn="ctr"/>
+            <a:r>
+              <a:rPr sz="750" b="1">
+                <a:solidFill>
+                  <a:srgbClr val="2E65B4"/>
+                </a:solidFill>
+              </a:rPr>
+              <a:t>16R/16W</a:t>
+            </a:r>
+          </a:p>
+        </p:txBody>
+      </p:sp>
+      <p:sp>
+        <p:nvSpPr>
+          <p:cNvPr id="65" name="Rounded Rectangle 64"/>
+          <p:cNvSpPr/>
+          <p:nvPr/>
+        </p:nvSpPr>
+        <p:spPr>
+          <a:xfrm>
+            <a:off x="2606040" y="6053328"/>
+            <a:ext cx="8595360" cy="438912"/>
+          </a:xfrm>
+          <a:prstGeom prst="roundRect">
+            <a:avLst/>
+          </a:prstGeom>
+          <a:solidFill>
+            <a:srgbClr val="5E6875"/>
+          </a:solidFill>
+          <a:ln>
+            <a:solidFill>
+              <a:srgbClr val="5E6875"/>
+            </a:solidFill>
+          </a:ln>
+        </p:spPr>
+        <p:style>
+          <a:lnRef idx="1">
+            <a:schemeClr val="accent1"/>
+          </a:lnRef>
+          <a:fillRef idx="3">
+            <a:schemeClr val="accent1"/>
+          </a:fillRef>
+          <a:effectRef idx="2">
+            <a:schemeClr val="accent1"/>
+          </a:effectRef>
+          <a:fontRef idx="minor">
+            <a:schemeClr val="lt1"/>
+          </a:fontRef>
+        </p:style>
+        <p:txBody>
+          <a:bodyPr rtlCol="0" anchor="ctr"/>
+          <a:lstStyle/>
+          <a:p>
+            <a:pPr algn="ctr"/>
+          </a:p>
+        </p:txBody>
+      </p:sp>
+      <p:sp>
+        <p:nvSpPr>
+          <p:cNvPr id="66" name="TextBox 65"/>
+          <p:cNvSpPr txBox="1"/>
+          <p:nvPr/>
+        </p:nvSpPr>
+        <p:spPr>
+          <a:xfrm>
+            <a:off x="2679192" y="6163056"/>
+            <a:ext cx="8449056" cy="228600"/>
+          </a:xfrm>
+          <a:prstGeom prst="rect">
+            <a:avLst/>
+          </a:prstGeom>
+          <a:noFill/>
+        </p:spPr>
+        <p:txBody>
+          <a:bodyPr wrap="square" lIns="36576" rIns="36576" tIns="18288" bIns="18288">
+            <a:spAutoFit/>
+          </a:bodyPr>
+          <a:lstStyle/>
+          <a:p>
+            <a:pPr algn="ctr"/>
+            <a:r>
+              <a:rPr sz="1200" b="1">
+                <a:solidFill>
+                  <a:srgbClr val="FFFFFF"/>
+                </a:solidFill>
+              </a:rPr>
+              <a:t>4 GB DRAM</a:t>
+            </a:r>
+          </a:p>
+        </p:txBody>
+      </p:sp>
+      <p:sp>
+        <p:nvSpPr>
+          <p:cNvPr id="67" name="TextBox 66"/>
+          <p:cNvSpPr txBox="1"/>
+          <p:nvPr/>
+        </p:nvSpPr>
+        <p:spPr>
+          <a:xfrm>
+            <a:off x="2715768" y="6446520"/>
+            <a:ext cx="8375904" cy="-18288"/>
+          </a:xfrm>
+          <a:prstGeom prst="rect">
+            <a:avLst/>
+          </a:prstGeom>
+          <a:noFill/>
+        </p:spPr>
+        <p:txBody>
+          <a:bodyPr wrap="square" lIns="36576" rIns="36576" tIns="18288" bIns="18288">
+            <a:spAutoFit/>
+          </a:bodyPr>
+          <a:lstStyle/>
+          <a:p>
+            <a:pPr algn="ctr"/>
+            <a:r>
+              <a:rPr sz="850" b="0">
+                <a:solidFill>
+                  <a:srgbClr val="FFFFFF"/>
+                </a:solidFill>
+              </a:rPr>
+              <a:t>LPDDR5X-10667 off-chip memory model</a:t>
+            </a:r>
+          </a:p>
+        </p:txBody>
+      </p:sp>
+      <p:cxnSp>
+        <p:nvCxnSpPr>
+          <p:cNvPr id="68" name="Connector 67"/>
+          <p:cNvCxnSpPr/>
+          <p:nvPr/>
+        </p:nvCxnSpPr>
+        <p:spPr>
+          <a:xfrm>
+            <a:off x="6629400" y="5852160"/>
+            <a:ext cx="0" cy="201168"/>
+          </a:xfrm>
+          <a:prstGeom prst="line">
+            <a:avLst/>
+          </a:prstGeom>
+          <a:ln w="17780">
+            <a:solidFill>
+              <a:srgbClr val="5E6875"/>
+            </a:solidFill>
+            <a:prstDash val="dash"/>
+          </a:ln>
+        </p:spPr>
+        <p:style>
+          <a:lnRef idx="2">
+            <a:schemeClr val="accent1"/>
+          </a:lnRef>
+          <a:fillRef idx="0">
+            <a:schemeClr val="accent1"/>
+          </a:fillRef>
+          <a:effectRef idx="1">
+            <a:schemeClr val="accent1"/>
+          </a:effectRef>
+          <a:fontRef idx="minor">
+            <a:schemeClr val="tx1"/>
+          </a:fontRef>
+        </p:style>
+      </p:cxnSp>
+      <p:cxnSp>
+        <p:nvCxnSpPr>
+          <p:cNvPr id="69" name="Connector 68"/>
+          <p:cNvCxnSpPr/>
+          <p:nvPr/>
+        </p:nvCxnSpPr>
+        <p:spPr>
+          <a:xfrm>
+            <a:off x="7178040" y="5852160"/>
+            <a:ext cx="0" cy="201168"/>
+          </a:xfrm>
+          <a:prstGeom prst="line">
+            <a:avLst/>
+          </a:prstGeom>
+          <a:ln w="17780">
+            <a:solidFill>
+              <a:srgbClr val="5E6875"/>
+            </a:solidFill>
+            <a:prstDash val="dash"/>
+          </a:ln>
+        </p:spPr>
+        <p:style>
+          <a:lnRef idx="2">
+            <a:schemeClr val="accent1"/>
+          </a:lnRef>
+          <a:fillRef idx="0">
+            <a:schemeClr val="accent1"/>
+          </a:fillRef>
+          <a:effectRef idx="1">
+            <a:schemeClr val="accent1"/>
+          </a:effectRef>
+          <a:fontRef idx="minor">
+            <a:schemeClr val="tx1"/>
+          </a:fontRef>
+        </p:style>
+      </p:cxnSp>
+      <p:sp>
+        <p:nvSpPr>
+          <p:cNvPr id="70" name="TextBox 69"/>
+          <p:cNvSpPr txBox="1"/>
+          <p:nvPr/>
+        </p:nvSpPr>
+        <p:spPr>
+          <a:xfrm>
+            <a:off x="6144768" y="5879592"/>
+            <a:ext cx="457200" cy="182880"/>
+          </a:xfrm>
+          <a:prstGeom prst="rect">
+            <a:avLst/>
+          </a:prstGeom>
+          <a:noFill/>
+        </p:spPr>
+        <p:txBody>
+          <a:bodyPr wrap="square" lIns="36576" rIns="36576" tIns="18288" bIns="18288">
+            <a:spAutoFit/>
+          </a:bodyPr>
+          <a:lstStyle/>
+          <a:p>
+            <a:pPr algn="ctr"/>
+            <a:r>
+              <a:rPr sz="750" b="1">
                 <a:solidFill>
                   <a:srgbClr val="5E6875"/>
                 </a:solidFill>
               </a:rPr>
-              <a:t>Date: 2026-05-09</a:t>
-            </a:r>
-          </a:p>
-        </p:txBody>
-      </p:sp>
-      <p:sp>
-        <p:nvSpPr>
-          <p:cNvPr id="20" name="TextBox 19"/>
-          <p:cNvSpPr txBox="1"/>
-          <p:nvPr/>
-        </p:nvSpPr>
-        <p:spPr>
-          <a:xfrm>
-            <a:off x="502920" y="6446520"/>
-            <a:ext cx="7315200" cy="228600"/>
-          </a:xfrm>
-          <a:prstGeom prst="rect">
-            <a:avLst/>
-          </a:prstGeom>
-          <a:noFill/>
-        </p:spPr>
-        <p:txBody>
-          <a:bodyPr wrap="square" lIns="36576" rIns="36576" tIns="18288" bIns="18288">
-            <a:spAutoFit/>
-          </a:bodyPr>
-          <a:lstStyle/>
-          <a:p>
+              <a:t>R</a:t>
+            </a:r>
+          </a:p>
+        </p:txBody>
+      </p:sp>
+      <p:sp>
+        <p:nvSpPr>
+          <p:cNvPr id="71" name="TextBox 70"/>
+          <p:cNvSpPr txBox="1"/>
+          <p:nvPr/>
+        </p:nvSpPr>
+        <p:spPr>
+          <a:xfrm>
+            <a:off x="7333488" y="5879592"/>
+            <a:ext cx="457200" cy="182880"/>
+          </a:xfrm>
+          <a:prstGeom prst="rect">
+            <a:avLst/>
+          </a:prstGeom>
+          <a:noFill/>
+        </p:spPr>
+        <p:txBody>
+          <a:bodyPr wrap="square" lIns="36576" rIns="36576" tIns="18288" bIns="18288">
+            <a:spAutoFit/>
+          </a:bodyPr>
+          <a:lstStyle/>
+          <a:p>
+            <a:pPr algn="ctr"/>
+            <a:r>
+              <a:rPr sz="750" b="1">
+                <a:solidFill>
+                  <a:srgbClr val="5E6875"/>
+                </a:solidFill>
+              </a:rPr>
+              <a:t>W</a:t>
+            </a:r>
+          </a:p>
+        </p:txBody>
+      </p:sp>
+      <p:sp>
+        <p:nvSpPr>
+          <p:cNvPr id="72" name="TextBox 71"/>
+          <p:cNvSpPr txBox="1"/>
+          <p:nvPr/>
+        </p:nvSpPr>
+        <p:spPr>
+          <a:xfrm>
+            <a:off x="502920" y="5715000"/>
+            <a:ext cx="1554480" cy="228600"/>
+          </a:xfrm>
+          <a:prstGeom prst="rect">
+            <a:avLst/>
+          </a:prstGeom>
+          <a:noFill/>
+        </p:spPr>
+        <p:txBody>
+          <a:bodyPr wrap="square" lIns="36576" rIns="36576" tIns="18288" bIns="18288">
+            <a:spAutoFit/>
+          </a:bodyPr>
+          <a:lstStyle/>
+          <a:p>
+            <a:pPr algn="l"/>
+            <a:r>
+              <a:rPr sz="1000" b="1">
+                <a:solidFill>
+                  <a:srgbClr val="183458"/>
+                </a:solidFill>
+              </a:rPr>
+              <a:t>Legend</a:t>
+            </a:r>
+          </a:p>
+        </p:txBody>
+      </p:sp>
+      <p:cxnSp>
+        <p:nvCxnSpPr>
+          <p:cNvPr id="73" name="Connector 72"/>
+          <p:cNvCxnSpPr/>
+          <p:nvPr/>
+        </p:nvCxnSpPr>
+        <p:spPr>
+          <a:xfrm>
+            <a:off x="548640" y="6053328"/>
+            <a:ext cx="502920" cy="0"/>
+          </a:xfrm>
+          <a:prstGeom prst="line">
+            <a:avLst/>
+          </a:prstGeom>
+          <a:ln w="29209">
+            <a:solidFill>
+              <a:srgbClr val="2E65B4"/>
+            </a:solidFill>
+          </a:ln>
+        </p:spPr>
+        <p:style>
+          <a:lnRef idx="2">
+            <a:schemeClr val="accent1"/>
+          </a:lnRef>
+          <a:fillRef idx="0">
+            <a:schemeClr val="accent1"/>
+          </a:fillRef>
+          <a:effectRef idx="1">
+            <a:schemeClr val="accent1"/>
+          </a:effectRef>
+          <a:fontRef idx="minor">
+            <a:schemeClr val="tx1"/>
+          </a:fontRef>
+        </p:style>
+      </p:cxnSp>
+      <p:sp>
+        <p:nvSpPr>
+          <p:cNvPr id="74" name="TextBox 73"/>
+          <p:cNvSpPr txBox="1"/>
+          <p:nvPr/>
+        </p:nvSpPr>
+        <p:spPr>
+          <a:xfrm>
+            <a:off x="1115568" y="5943600"/>
+            <a:ext cx="1280160" cy="228600"/>
+          </a:xfrm>
+          <a:prstGeom prst="rect">
+            <a:avLst/>
+          </a:prstGeom>
+          <a:noFill/>
+        </p:spPr>
+        <p:txBody>
+          <a:bodyPr wrap="square" lIns="36576" rIns="36576" tIns="18288" bIns="18288">
+            <a:spAutoFit/>
+          </a:bodyPr>
+          <a:lstStyle/>
+          <a:p>
+            <a:pPr algn="l"/>
             <a:r>
               <a:rPr sz="800" b="0">
                 <a:solidFill>
                   <a:srgbClr val="5E6875"/>
                 </a:solidFill>
               </a:rPr>
-              <a:t>MDLA7 SystemC Performance Model | internal technical briefing</a:t>
-            </a:r>
-          </a:p>
-        </p:txBody>
-      </p:sp>
-      <p:sp>
-        <p:nvSpPr>
-          <p:cNvPr id="21" name="TextBox 20"/>
-          <p:cNvSpPr txBox="1"/>
-          <p:nvPr/>
-        </p:nvSpPr>
-        <p:spPr>
-          <a:xfrm>
-            <a:off x="11064240" y="6446520"/>
-            <a:ext cx="640080" cy="228600"/>
+              <a:t>Payload lanes</a:t>
+            </a:r>
+          </a:p>
+        </p:txBody>
+      </p:sp>
+      <p:cxnSp>
+        <p:nvCxnSpPr>
+          <p:cNvPr id="75" name="Connector 74"/>
+          <p:cNvCxnSpPr/>
+          <p:nvPr/>
+        </p:nvCxnSpPr>
+        <p:spPr>
+          <a:xfrm>
+            <a:off x="548640" y="6336792"/>
+            <a:ext cx="502920" cy="0"/>
+          </a:xfrm>
+          <a:prstGeom prst="line">
+            <a:avLst/>
+          </a:prstGeom>
+          <a:ln w="17780">
+            <a:solidFill>
+              <a:srgbClr val="5E6875"/>
+            </a:solidFill>
+            <a:prstDash val="dash"/>
+          </a:ln>
+        </p:spPr>
+        <p:style>
+          <a:lnRef idx="2">
+            <a:schemeClr val="accent1"/>
+          </a:lnRef>
+          <a:fillRef idx="0">
+            <a:schemeClr val="accent1"/>
+          </a:fillRef>
+          <a:effectRef idx="1">
+            <a:schemeClr val="accent1"/>
+          </a:effectRef>
+          <a:fontRef idx="minor">
+            <a:schemeClr val="tx1"/>
+          </a:fontRef>
+        </p:style>
+      </p:cxnSp>
+      <p:sp>
+        <p:nvSpPr>
+          <p:cNvPr id="76" name="TextBox 75"/>
+          <p:cNvSpPr txBox="1"/>
+          <p:nvPr/>
+        </p:nvSpPr>
+        <p:spPr>
+          <a:xfrm>
+            <a:off x="1115568" y="6227064"/>
+            <a:ext cx="1508760" cy="228600"/>
+          </a:xfrm>
+          <a:prstGeom prst="rect">
+            <a:avLst/>
+          </a:prstGeom>
+          <a:noFill/>
+        </p:spPr>
+        <p:txBody>
+          <a:bodyPr wrap="square" lIns="36576" rIns="36576" tIns="18288" bIns="18288">
+            <a:spAutoFit/>
+          </a:bodyPr>
+          <a:lstStyle/>
+          <a:p>
+            <a:pPr algn="l"/>
+            <a:r>
+              <a:rPr sz="800" b="0">
+                <a:solidFill>
+                  <a:srgbClr val="5E6875"/>
+                </a:solidFill>
+              </a:rPr>
+              <a:t>1T config/control</a:t>
+            </a:r>
+          </a:p>
+        </p:txBody>
+      </p:sp>
+      <p:sp>
+        <p:nvSpPr>
+          <p:cNvPr id="77" name="TextBox 76"/>
+          <p:cNvSpPr txBox="1"/>
+          <p:nvPr/>
+        </p:nvSpPr>
+        <p:spPr>
+          <a:xfrm>
+            <a:off x="9646920" y="6473952"/>
+            <a:ext cx="2011680" cy="201168"/>
           </a:xfrm>
           <a:prstGeom prst="rect">
             <a:avLst/>

</xml_diff>